<commit_message>
fix: Einheitliches Typografie-System für PowerPoint
Schriftgrößen jetzt konsistent:
- Section Header: 11pt (Gold, Uppercase)
- Haupttitel: 32pt
- Karten-Titel/Subtitel: 14pt
- Body/Bullets: 14pt
- Highlight-Box: 17pt
- Kleine Texte: 11pt
- Footer: 10pt

Einheitliche Y-Positionen:
- Section: 0.4"
- Titel: 0.75"
- Content: 1.8"
- Highlight: 5.4"
- Footer: 7.05"

https://claude.ai/code/session_01WBm8xw2iNySy71JbFi5gJp
</commit_message>
<xml_diff>
--- a/presentations/Neuratex_AI_Praesentation.pptx
+++ b/presentations/Neuratex_AI_Praesentation.pptx
@@ -3538,8 +3538,8 @@
         </p:nvSpPr>
         <p:spPr>
           <a:xfrm>
-            <a:off x="0" y="2926080"/>
-            <a:ext cx="137160" cy="1645920"/>
+            <a:off x="0" y="2560320"/>
+            <a:ext cx="109728" cy="1828800"/>
           </a:xfrm>
           <a:prstGeom prst="rect">
             <a:avLst/>
@@ -3581,8 +3581,8 @@
         </p:nvSpPr>
         <p:spPr>
           <a:xfrm>
-            <a:off x="731520" y="1645920"/>
-            <a:ext cx="7315200" cy="457200"/>
+            <a:off x="640080" y="1463040"/>
+            <a:ext cx="7315200" cy="365760"/>
           </a:xfrm>
           <a:prstGeom prst="rect">
             <a:avLst/>
@@ -3597,9 +3597,9 @@
           <a:p>
             <a:pPr algn="l">
               <a:lnSpc>
-                <a:spcPct val="140000"/>
+                <a:spcPct val="130000"/>
               </a:lnSpc>
-              <a:defRPr sz="2600" b="0">
+              <a:defRPr sz="2400" b="0">
                 <a:solidFill>
                   <a:srgbClr val="CBD5E1"/>
                 </a:solidFill>
@@ -3620,8 +3620,8 @@
         </p:nvSpPr>
         <p:spPr>
           <a:xfrm>
-            <a:off x="731520" y="2148840"/>
-            <a:ext cx="7315200" cy="457200"/>
+            <a:off x="640080" y="1920240"/>
+            <a:ext cx="7315200" cy="365760"/>
           </a:xfrm>
           <a:prstGeom prst="rect">
             <a:avLst/>
@@ -3636,9 +3636,9 @@
           <a:p>
             <a:pPr algn="l">
               <a:lnSpc>
-                <a:spcPct val="140000"/>
+                <a:spcPct val="130000"/>
               </a:lnSpc>
-              <a:defRPr sz="2600" b="0">
+              <a:defRPr sz="2400" b="0">
                 <a:solidFill>
                   <a:srgbClr val="CBD5E1"/>
                 </a:solidFill>
@@ -3659,8 +3659,8 @@
         </p:nvSpPr>
         <p:spPr>
           <a:xfrm>
-            <a:off x="731520" y="2651760"/>
-            <a:ext cx="7315200" cy="457200"/>
+            <a:off x="640080" y="2377440"/>
+            <a:ext cx="7315200" cy="365760"/>
           </a:xfrm>
           <a:prstGeom prst="rect">
             <a:avLst/>
@@ -3675,9 +3675,9 @@
           <a:p>
             <a:pPr algn="l">
               <a:lnSpc>
-                <a:spcPct val="140000"/>
+                <a:spcPct val="130000"/>
               </a:lnSpc>
-              <a:defRPr sz="2600" b="0">
+              <a:defRPr sz="2400" b="0">
                 <a:solidFill>
                   <a:srgbClr val="CBD5E1"/>
                 </a:solidFill>
@@ -3698,8 +3698,8 @@
         </p:nvSpPr>
         <p:spPr>
           <a:xfrm>
-            <a:off x="731520" y="3474720"/>
-            <a:ext cx="7315200" cy="914400"/>
+            <a:off x="640080" y="3200400"/>
+            <a:ext cx="7315200" cy="731520"/>
           </a:xfrm>
           <a:prstGeom prst="rect">
             <a:avLst/>
@@ -3714,9 +3714,9 @@
           <a:p>
             <a:pPr algn="l">
               <a:lnSpc>
-                <a:spcPct val="140000"/>
+                <a:spcPct val="130000"/>
               </a:lnSpc>
-              <a:defRPr sz="5200" b="1">
+              <a:defRPr sz="4800" b="1">
                 <a:solidFill>
                   <a:srgbClr val="FFC947"/>
                 </a:solidFill>
@@ -3737,8 +3737,8 @@
         </p:nvSpPr>
         <p:spPr>
           <a:xfrm>
-            <a:off x="731520" y="4572000"/>
-            <a:ext cx="7315200" cy="457200"/>
+            <a:off x="640080" y="4114800"/>
+            <a:ext cx="7315200" cy="365760"/>
           </a:xfrm>
           <a:prstGeom prst="rect">
             <a:avLst/>
@@ -3753,7 +3753,7 @@
           <a:p>
             <a:pPr algn="l">
               <a:lnSpc>
-                <a:spcPct val="140000"/>
+                <a:spcPct val="130000"/>
               </a:lnSpc>
               <a:defRPr sz="1800" b="0">
                 <a:solidFill>
@@ -3784,8 +3784,8 @@
         </p:blipFill>
         <p:spPr>
           <a:xfrm>
-            <a:off x="6217920" y="1371600"/>
-            <a:ext cx="2560320" cy="1533299"/>
+            <a:off x="5943600" y="1188720"/>
+            <a:ext cx="2743200" cy="1642820"/>
           </a:xfrm>
           <a:prstGeom prst="rect">
             <a:avLst/>
@@ -3800,7 +3800,7 @@
         </p:nvSpPr>
         <p:spPr>
           <a:xfrm>
-            <a:off x="0" y="6492240"/>
+            <a:off x="0" y="6446520"/>
             <a:ext cx="9144000" cy="25400"/>
           </a:xfrm>
           <a:prstGeom prst="rect">
@@ -3843,8 +3843,8 @@
         </p:nvSpPr>
         <p:spPr>
           <a:xfrm>
-            <a:off x="457200" y="6537960"/>
-            <a:ext cx="8229600" cy="274320"/>
+            <a:off x="365760" y="6510528"/>
+            <a:ext cx="8229600" cy="228600"/>
           </a:xfrm>
           <a:prstGeom prst="rect">
             <a:avLst/>
@@ -3905,8 +3905,8 @@
         </p:nvSpPr>
         <p:spPr>
           <a:xfrm>
-            <a:off x="457200" y="457200"/>
-            <a:ext cx="7315200" cy="365760"/>
+            <a:off x="365760" y="365760"/>
+            <a:ext cx="7315200" cy="274320"/>
           </a:xfrm>
           <a:prstGeom prst="rect">
             <a:avLst/>
@@ -3920,7 +3920,7 @@
           <a:lstStyle/>
           <a:p>
             <a:pPr>
-              <a:defRPr sz="1200" b="1">
+              <a:defRPr sz="1100" b="1">
                 <a:solidFill>
                   <a:srgbClr val="FFC947"/>
                 </a:solidFill>
@@ -3941,8 +3941,8 @@
         </p:nvSpPr>
         <p:spPr>
           <a:xfrm>
-            <a:off x="457200" y="822960"/>
-            <a:ext cx="7315200" cy="1097280"/>
+            <a:off x="365760" y="685800"/>
+            <a:ext cx="8229600" cy="822960"/>
           </a:xfrm>
           <a:prstGeom prst="rect">
             <a:avLst/>
@@ -3956,7 +3956,7 @@
           <a:lstStyle/>
           <a:p>
             <a:pPr>
-              <a:defRPr sz="3600" b="1">
+              <a:defRPr sz="3200" b="1">
                 <a:solidFill>
                   <a:srgbClr val="F8FAFC"/>
                 </a:solidFill>
@@ -3977,8 +3977,8 @@
         </p:nvSpPr>
         <p:spPr>
           <a:xfrm>
-            <a:off x="457200" y="1920240"/>
-            <a:ext cx="320040" cy="320040"/>
+            <a:off x="365760" y="1737360"/>
+            <a:ext cx="411480" cy="411480"/>
           </a:xfrm>
           <a:prstGeom prst="ellipse">
             <a:avLst/>
@@ -4009,7 +4009,7 @@
           <a:lstStyle/>
           <a:p>
             <a:pPr algn="ctr">
-              <a:defRPr sz="1400" b="1">
+              <a:defRPr sz="1600" b="1">
                 <a:solidFill>
                   <a:srgbClr val="0A1931"/>
                 </a:solidFill>
@@ -4029,8 +4029,8 @@
         </p:nvSpPr>
         <p:spPr>
           <a:xfrm>
-            <a:off x="914400" y="1920240"/>
-            <a:ext cx="3657600" cy="822960"/>
+            <a:off x="914400" y="1810512"/>
+            <a:ext cx="7772400" cy="365760"/>
           </a:xfrm>
           <a:prstGeom prst="rect">
             <a:avLst/>
@@ -4045,7 +4045,7 @@
           <a:p>
             <a:pPr algn="l">
               <a:lnSpc>
-                <a:spcPct val="140000"/>
+                <a:spcPct val="130000"/>
               </a:lnSpc>
               <a:defRPr sz="1400" b="0">
                 <a:solidFill>
@@ -4055,11 +4055,7 @@
               </a:defRPr>
             </a:pPr>
             <a:r>
-              <a:t>Neue ERP-/CRM-Einführungen erhöhen</a:t>
-            </a:r>
-            <a:br/>
-            <a:r>
-              <a:t>Sichtbarkeit von Datenproblemen</a:t>
+              <a:t>Neue ERP-/CRM-Einführungen erhöhen Sichtbarkeit von Datenproblemen</a:t>
             </a:r>
           </a:p>
         </p:txBody>
@@ -4072,8 +4068,8 @@
         </p:nvSpPr>
         <p:spPr>
           <a:xfrm>
-            <a:off x="4572000" y="1920240"/>
-            <a:ext cx="320040" cy="320040"/>
+            <a:off x="365760" y="2377439"/>
+            <a:ext cx="411480" cy="411480"/>
           </a:xfrm>
           <a:prstGeom prst="ellipse">
             <a:avLst/>
@@ -4104,7 +4100,7 @@
           <a:lstStyle/>
           <a:p>
             <a:pPr algn="ctr">
-              <a:defRPr sz="1400" b="1">
+              <a:defRPr sz="1600" b="1">
                 <a:solidFill>
                   <a:srgbClr val="0A1931"/>
                 </a:solidFill>
@@ -4124,8 +4120,8 @@
         </p:nvSpPr>
         <p:spPr>
           <a:xfrm>
-            <a:off x="5029200" y="1920240"/>
-            <a:ext cx="3657600" cy="822960"/>
+            <a:off x="914400" y="2450591"/>
+            <a:ext cx="7772400" cy="365760"/>
           </a:xfrm>
           <a:prstGeom prst="rect">
             <a:avLst/>
@@ -4140,7 +4136,7 @@
           <a:p>
             <a:pPr algn="l">
               <a:lnSpc>
-                <a:spcPct val="140000"/>
+                <a:spcPct val="130000"/>
               </a:lnSpc>
               <a:defRPr sz="1400" b="0">
                 <a:solidFill>
@@ -4150,11 +4146,7 @@
               </a:defRPr>
             </a:pPr>
             <a:r>
-              <a:t>Ohne saubere Dokumentbasis werden</a:t>
-            </a:r>
-            <a:br/>
-            <a:r>
-              <a:t>neue Systeme langsamer akzeptiert</a:t>
+              <a:t>Ohne saubere Dokumentbasis werden neue Systeme langsamer akzeptiert</a:t>
             </a:r>
           </a:p>
         </p:txBody>
@@ -4167,8 +4159,8 @@
         </p:nvSpPr>
         <p:spPr>
           <a:xfrm>
-            <a:off x="457200" y="3291840"/>
-            <a:ext cx="320040" cy="320040"/>
+            <a:off x="365760" y="3017520"/>
+            <a:ext cx="411480" cy="411480"/>
           </a:xfrm>
           <a:prstGeom prst="ellipse">
             <a:avLst/>
@@ -4199,7 +4191,7 @@
           <a:lstStyle/>
           <a:p>
             <a:pPr algn="ctr">
-              <a:defRPr sz="1400" b="1">
+              <a:defRPr sz="1600" b="1">
                 <a:solidFill>
                   <a:srgbClr val="0A1931"/>
                 </a:solidFill>
@@ -4219,8 +4211,8 @@
         </p:nvSpPr>
         <p:spPr>
           <a:xfrm>
-            <a:off x="914400" y="3291840"/>
-            <a:ext cx="3657600" cy="822960"/>
+            <a:off x="914400" y="3090672"/>
+            <a:ext cx="7772400" cy="365760"/>
           </a:xfrm>
           <a:prstGeom prst="rect">
             <a:avLst/>
@@ -4235,7 +4227,7 @@
           <a:p>
             <a:pPr algn="l">
               <a:lnSpc>
-                <a:spcPct val="140000"/>
+                <a:spcPct val="130000"/>
               </a:lnSpc>
               <a:defRPr sz="1400" b="0">
                 <a:solidFill>
@@ -4245,11 +4237,7 @@
               </a:defRPr>
             </a:pPr>
             <a:r>
-              <a:t>Wissensverlust durch Renteneintritte</a:t>
-            </a:r>
-            <a:br/>
-            <a:r>
-              <a:t>ist planbar, aber oft unvorbereitet</a:t>
+              <a:t>Wissensverlust durch Renteneintritte ist planbar, aber oft unvorbereitet</a:t>
             </a:r>
           </a:p>
         </p:txBody>
@@ -4262,8 +4250,8 @@
         </p:nvSpPr>
         <p:spPr>
           <a:xfrm>
-            <a:off x="4572000" y="3291840"/>
-            <a:ext cx="320040" cy="320040"/>
+            <a:off x="365760" y="3657600"/>
+            <a:ext cx="411480" cy="411480"/>
           </a:xfrm>
           <a:prstGeom prst="ellipse">
             <a:avLst/>
@@ -4294,7 +4282,7 @@
           <a:lstStyle/>
           <a:p>
             <a:pPr algn="ctr">
-              <a:defRPr sz="1400" b="1">
+              <a:defRPr sz="1600" b="1">
                 <a:solidFill>
                   <a:srgbClr val="0A1931"/>
                 </a:solidFill>
@@ -4314,8 +4302,8 @@
         </p:nvSpPr>
         <p:spPr>
           <a:xfrm>
-            <a:off x="5029200" y="3291840"/>
-            <a:ext cx="3657600" cy="822960"/>
+            <a:off x="914400" y="3730752"/>
+            <a:ext cx="7772400" cy="365760"/>
           </a:xfrm>
           <a:prstGeom prst="rect">
             <a:avLst/>
@@ -4330,7 +4318,7 @@
           <a:p>
             <a:pPr algn="l">
               <a:lnSpc>
-                <a:spcPct val="140000"/>
+                <a:spcPct val="130000"/>
               </a:lnSpc>
               <a:defRPr sz="1400" b="0">
                 <a:solidFill>
@@ -4340,11 +4328,7 @@
               </a:defRPr>
             </a:pPr>
             <a:r>
-              <a:t>Service-Anfragen steigen,</a:t>
-            </a:r>
-            <a:br/>
-            <a:r>
-              <a:t>während Fachkräfte knapp sind</a:t>
+              <a:t>Service-Anfragen steigen, während Fachkräfte knapp sind</a:t>
             </a:r>
           </a:p>
         </p:txBody>
@@ -4357,12 +4341,12 @@
         </p:nvSpPr>
         <p:spPr>
           <a:xfrm>
-            <a:off x="457200" y="4846320"/>
-            <a:ext cx="8229600" cy="1005840"/>
+            <a:off x="365760" y="4937760"/>
+            <a:ext cx="8412480" cy="914400"/>
           </a:xfrm>
           <a:prstGeom prst="roundRect">
             <a:avLst>
-              <a:gd name="adj" fmla="val 10000"/>
+              <a:gd name="adj" fmla="val 8000"/>
             </a:avLst>
           </a:prstGeom>
           <a:solidFill>
@@ -4392,7 +4376,7 @@
           <a:p>
             <a:pPr algn="ctr">
               <a:lnSpc>
-                <a:spcPct val="130000"/>
+                <a:spcPct val="120000"/>
               </a:lnSpc>
               <a:defRPr sz="1700" b="1">
                 <a:solidFill>
@@ -4427,7 +4411,7 @@
         </p:blipFill>
         <p:spPr>
           <a:xfrm>
-            <a:off x="7589520" y="274320"/>
+            <a:off x="7589520" y="228600"/>
             <a:ext cx="1188720" cy="711889"/>
           </a:xfrm>
           <a:prstGeom prst="rect">
@@ -4443,7 +4427,7 @@
         </p:nvSpPr>
         <p:spPr>
           <a:xfrm>
-            <a:off x="0" y="6492240"/>
+            <a:off x="0" y="6446520"/>
             <a:ext cx="9144000" cy="25400"/>
           </a:xfrm>
           <a:prstGeom prst="rect">
@@ -4486,8 +4470,8 @@
         </p:nvSpPr>
         <p:spPr>
           <a:xfrm>
-            <a:off x="457200" y="6537960"/>
-            <a:ext cx="8229600" cy="274320"/>
+            <a:off x="365760" y="6510528"/>
+            <a:ext cx="8229600" cy="228600"/>
           </a:xfrm>
           <a:prstGeom prst="rect">
             <a:avLst/>
@@ -4548,8 +4532,8 @@
         </p:nvSpPr>
         <p:spPr>
           <a:xfrm>
-            <a:off x="457200" y="457200"/>
-            <a:ext cx="7315200" cy="365760"/>
+            <a:off x="365760" y="365760"/>
+            <a:ext cx="7315200" cy="274320"/>
           </a:xfrm>
           <a:prstGeom prst="rect">
             <a:avLst/>
@@ -4563,7 +4547,7 @@
           <a:lstStyle/>
           <a:p>
             <a:pPr>
-              <a:defRPr sz="1200" b="1">
+              <a:defRPr sz="1100" b="1">
                 <a:solidFill>
                   <a:srgbClr val="FFC947"/>
                 </a:solidFill>
@@ -4584,8 +4568,8 @@
         </p:nvSpPr>
         <p:spPr>
           <a:xfrm>
-            <a:off x="457200" y="822960"/>
-            <a:ext cx="7315200" cy="1097280"/>
+            <a:off x="365760" y="685800"/>
+            <a:ext cx="8229600" cy="822960"/>
           </a:xfrm>
           <a:prstGeom prst="rect">
             <a:avLst/>
@@ -4599,7 +4583,7 @@
           <a:lstStyle/>
           <a:p>
             <a:pPr>
-              <a:defRPr sz="3600" b="1">
+              <a:defRPr sz="3200" b="1">
                 <a:solidFill>
                   <a:srgbClr val="F8FAFC"/>
                 </a:solidFill>
@@ -4620,8 +4604,8 @@
         </p:nvSpPr>
         <p:spPr>
           <a:xfrm>
-            <a:off x="457200" y="2011680"/>
-            <a:ext cx="502920" cy="502920"/>
+            <a:off x="365760" y="1737360"/>
+            <a:ext cx="411480" cy="411480"/>
           </a:xfrm>
           <a:prstGeom prst="ellipse">
             <a:avLst/>
@@ -4652,7 +4636,7 @@
           <a:lstStyle/>
           <a:p>
             <a:pPr algn="ctr">
-              <a:defRPr sz="1800" b="1">
+              <a:defRPr sz="1600" b="1">
                 <a:solidFill>
                   <a:srgbClr val="0A1931"/>
                 </a:solidFill>
@@ -4672,8 +4656,8 @@
         </p:nvSpPr>
         <p:spPr>
           <a:xfrm>
-            <a:off x="1097280" y="2011680"/>
-            <a:ext cx="2743200" cy="365760"/>
+            <a:off x="914400" y="1737360"/>
+            <a:ext cx="2743200" cy="320040"/>
           </a:xfrm>
           <a:prstGeom prst="rect">
             <a:avLst/>
@@ -4688,9 +4672,9 @@
           <a:p>
             <a:pPr algn="l">
               <a:lnSpc>
-                <a:spcPct val="140000"/>
+                <a:spcPct val="130000"/>
               </a:lnSpc>
-              <a:defRPr sz="1800" b="1">
+              <a:defRPr sz="1600" b="1">
                 <a:solidFill>
                   <a:srgbClr val="FFC947"/>
                 </a:solidFill>
@@ -4711,8 +4695,8 @@
         </p:nvSpPr>
         <p:spPr>
           <a:xfrm>
-            <a:off x="1097280" y="2331720"/>
-            <a:ext cx="7315200" cy="320040"/>
+            <a:off x="914400" y="2057400"/>
+            <a:ext cx="7315200" cy="274320"/>
           </a:xfrm>
           <a:prstGeom prst="rect">
             <a:avLst/>
@@ -4727,7 +4711,7 @@
           <a:p>
             <a:pPr algn="l">
               <a:lnSpc>
-                <a:spcPct val="140000"/>
+                <a:spcPct val="130000"/>
               </a:lnSpc>
               <a:defRPr sz="1400" b="0">
                 <a:solidFill>
@@ -4750,8 +4734,8 @@
         </p:nvSpPr>
         <p:spPr>
           <a:xfrm>
-            <a:off x="457200" y="2788920"/>
-            <a:ext cx="502920" cy="502920"/>
+            <a:off x="365760" y="2468880"/>
+            <a:ext cx="411480" cy="411480"/>
           </a:xfrm>
           <a:prstGeom prst="ellipse">
             <a:avLst/>
@@ -4782,7 +4766,7 @@
           <a:lstStyle/>
           <a:p>
             <a:pPr algn="ctr">
-              <a:defRPr sz="1800" b="1">
+              <a:defRPr sz="1600" b="1">
                 <a:solidFill>
                   <a:srgbClr val="0A1931"/>
                 </a:solidFill>
@@ -4802,8 +4786,8 @@
         </p:nvSpPr>
         <p:spPr>
           <a:xfrm>
-            <a:off x="1097280" y="2788920"/>
-            <a:ext cx="2743200" cy="365760"/>
+            <a:off x="914400" y="2468880"/>
+            <a:ext cx="2743200" cy="320040"/>
           </a:xfrm>
           <a:prstGeom prst="rect">
             <a:avLst/>
@@ -4818,9 +4802,9 @@
           <a:p>
             <a:pPr algn="l">
               <a:lnSpc>
-                <a:spcPct val="140000"/>
+                <a:spcPct val="130000"/>
               </a:lnSpc>
-              <a:defRPr sz="1800" b="1">
+              <a:defRPr sz="1600" b="1">
                 <a:solidFill>
                   <a:srgbClr val="FFC947"/>
                 </a:solidFill>
@@ -4841,8 +4825,8 @@
         </p:nvSpPr>
         <p:spPr>
           <a:xfrm>
-            <a:off x="1097280" y="3108960"/>
-            <a:ext cx="7315200" cy="320040"/>
+            <a:off x="914400" y="2788920"/>
+            <a:ext cx="7315200" cy="274320"/>
           </a:xfrm>
           <a:prstGeom prst="rect">
             <a:avLst/>
@@ -4857,7 +4841,7 @@
           <a:p>
             <a:pPr algn="l">
               <a:lnSpc>
-                <a:spcPct val="140000"/>
+                <a:spcPct val="130000"/>
               </a:lnSpc>
               <a:defRPr sz="1400" b="0">
                 <a:solidFill>
@@ -4880,8 +4864,8 @@
         </p:nvSpPr>
         <p:spPr>
           <a:xfrm>
-            <a:off x="457200" y="3566160"/>
-            <a:ext cx="502920" cy="502920"/>
+            <a:off x="365760" y="3200400"/>
+            <a:ext cx="411480" cy="411480"/>
           </a:xfrm>
           <a:prstGeom prst="ellipse">
             <a:avLst/>
@@ -4912,7 +4896,7 @@
           <a:lstStyle/>
           <a:p>
             <a:pPr algn="ctr">
-              <a:defRPr sz="1800" b="1">
+              <a:defRPr sz="1600" b="1">
                 <a:solidFill>
                   <a:srgbClr val="0A1931"/>
                 </a:solidFill>
@@ -4932,8 +4916,8 @@
         </p:nvSpPr>
         <p:spPr>
           <a:xfrm>
-            <a:off x="1097280" y="3566160"/>
-            <a:ext cx="2743200" cy="365760"/>
+            <a:off x="914400" y="3200400"/>
+            <a:ext cx="2743200" cy="320040"/>
           </a:xfrm>
           <a:prstGeom prst="rect">
             <a:avLst/>
@@ -4948,9 +4932,9 @@
           <a:p>
             <a:pPr algn="l">
               <a:lnSpc>
-                <a:spcPct val="140000"/>
+                <a:spcPct val="130000"/>
               </a:lnSpc>
-              <a:defRPr sz="1800" b="1">
+              <a:defRPr sz="1600" b="1">
                 <a:solidFill>
                   <a:srgbClr val="FFC947"/>
                 </a:solidFill>
@@ -4971,8 +4955,8 @@
         </p:nvSpPr>
         <p:spPr>
           <a:xfrm>
-            <a:off x="1097280" y="3886200"/>
-            <a:ext cx="7315200" cy="320040"/>
+            <a:off x="914400" y="3520440"/>
+            <a:ext cx="7315200" cy="274320"/>
           </a:xfrm>
           <a:prstGeom prst="rect">
             <a:avLst/>
@@ -4987,7 +4971,7 @@
           <a:p>
             <a:pPr algn="l">
               <a:lnSpc>
-                <a:spcPct val="140000"/>
+                <a:spcPct val="130000"/>
               </a:lnSpc>
               <a:defRPr sz="1400" b="0">
                 <a:solidFill>
@@ -5010,8 +4994,8 @@
         </p:nvSpPr>
         <p:spPr>
           <a:xfrm>
-            <a:off x="457200" y="4343400"/>
-            <a:ext cx="502920" cy="502920"/>
+            <a:off x="365760" y="3931920"/>
+            <a:ext cx="411480" cy="411480"/>
           </a:xfrm>
           <a:prstGeom prst="ellipse">
             <a:avLst/>
@@ -5042,7 +5026,7 @@
           <a:lstStyle/>
           <a:p>
             <a:pPr algn="ctr">
-              <a:defRPr sz="1800" b="1">
+              <a:defRPr sz="1600" b="1">
                 <a:solidFill>
                   <a:srgbClr val="0A1931"/>
                 </a:solidFill>
@@ -5062,8 +5046,8 @@
         </p:nvSpPr>
         <p:spPr>
           <a:xfrm>
-            <a:off x="1097280" y="4343400"/>
-            <a:ext cx="2743200" cy="365760"/>
+            <a:off x="914400" y="3931920"/>
+            <a:ext cx="2743200" cy="320040"/>
           </a:xfrm>
           <a:prstGeom prst="rect">
             <a:avLst/>
@@ -5078,9 +5062,9 @@
           <a:p>
             <a:pPr algn="l">
               <a:lnSpc>
-                <a:spcPct val="140000"/>
+                <a:spcPct val="130000"/>
               </a:lnSpc>
-              <a:defRPr sz="1800" b="1">
+              <a:defRPr sz="1600" b="1">
                 <a:solidFill>
                   <a:srgbClr val="FFC947"/>
                 </a:solidFill>
@@ -5101,8 +5085,8 @@
         </p:nvSpPr>
         <p:spPr>
           <a:xfrm>
-            <a:off x="1097280" y="4663440"/>
-            <a:ext cx="7315200" cy="320040"/>
+            <a:off x="914400" y="4251959"/>
+            <a:ext cx="7315200" cy="274320"/>
           </a:xfrm>
           <a:prstGeom prst="rect">
             <a:avLst/>
@@ -5117,7 +5101,7 @@
           <a:p>
             <a:pPr algn="l">
               <a:lnSpc>
-                <a:spcPct val="140000"/>
+                <a:spcPct val="130000"/>
               </a:lnSpc>
               <a:defRPr sz="1400" b="0">
                 <a:solidFill>
@@ -5140,12 +5124,12 @@
         </p:nvSpPr>
         <p:spPr>
           <a:xfrm>
-            <a:off x="457200" y="5212080"/>
-            <a:ext cx="8229600" cy="731520"/>
+            <a:off x="365760" y="4937760"/>
+            <a:ext cx="8412480" cy="914400"/>
           </a:xfrm>
           <a:prstGeom prst="roundRect">
             <a:avLst>
-              <a:gd name="adj" fmla="val 10000"/>
+              <a:gd name="adj" fmla="val 8000"/>
             </a:avLst>
           </a:prstGeom>
           <a:solidFill>
@@ -5175,9 +5159,9 @@
           <a:p>
             <a:pPr algn="ctr">
               <a:lnSpc>
-                <a:spcPct val="130000"/>
+                <a:spcPct val="120000"/>
               </a:lnSpc>
-              <a:defRPr sz="1800" b="1">
+              <a:defRPr sz="1700" b="1">
                 <a:solidFill>
                   <a:srgbClr val="0A1931"/>
                 </a:solidFill>
@@ -5206,7 +5190,7 @@
         </p:blipFill>
         <p:spPr>
           <a:xfrm>
-            <a:off x="7589520" y="274320"/>
+            <a:off x="7589520" y="228600"/>
             <a:ext cx="1188720" cy="711889"/>
           </a:xfrm>
           <a:prstGeom prst="rect">
@@ -5222,7 +5206,7 @@
         </p:nvSpPr>
         <p:spPr>
           <a:xfrm>
-            <a:off x="0" y="6492240"/>
+            <a:off x="0" y="6446520"/>
             <a:ext cx="9144000" cy="25400"/>
           </a:xfrm>
           <a:prstGeom prst="rect">
@@ -5265,8 +5249,8 @@
         </p:nvSpPr>
         <p:spPr>
           <a:xfrm>
-            <a:off x="457200" y="6537960"/>
-            <a:ext cx="8229600" cy="274320"/>
+            <a:off x="365760" y="6510528"/>
+            <a:ext cx="8229600" cy="228600"/>
           </a:xfrm>
           <a:prstGeom prst="rect">
             <a:avLst/>
@@ -5327,8 +5311,8 @@
         </p:nvSpPr>
         <p:spPr>
           <a:xfrm>
-            <a:off x="457200" y="457200"/>
-            <a:ext cx="7315200" cy="365760"/>
+            <a:off x="365760" y="365760"/>
+            <a:ext cx="7315200" cy="274320"/>
           </a:xfrm>
           <a:prstGeom prst="rect">
             <a:avLst/>
@@ -5342,7 +5326,7 @@
           <a:lstStyle/>
           <a:p>
             <a:pPr>
-              <a:defRPr sz="1200" b="1">
+              <a:defRPr sz="1100" b="1">
                 <a:solidFill>
                   <a:srgbClr val="FFC947"/>
                 </a:solidFill>
@@ -5363,8 +5347,8 @@
         </p:nvSpPr>
         <p:spPr>
           <a:xfrm>
-            <a:off x="457200" y="822960"/>
-            <a:ext cx="7315200" cy="1097280"/>
+            <a:off x="365760" y="685800"/>
+            <a:ext cx="8229600" cy="822960"/>
           </a:xfrm>
           <a:prstGeom prst="rect">
             <a:avLst/>
@@ -5378,7 +5362,7 @@
           <a:lstStyle/>
           <a:p>
             <a:pPr>
-              <a:defRPr sz="3600" b="1">
+              <a:defRPr sz="3200" b="1">
                 <a:solidFill>
                   <a:srgbClr val="F8FAFC"/>
                 </a:solidFill>
@@ -5399,8 +5383,8 @@
         </p:nvSpPr>
         <p:spPr>
           <a:xfrm>
-            <a:off x="457200" y="2011680"/>
-            <a:ext cx="8229600" cy="365760"/>
+            <a:off x="365760" y="1645920"/>
+            <a:ext cx="8229600" cy="320040"/>
           </a:xfrm>
           <a:prstGeom prst="rect">
             <a:avLst/>
@@ -5415,9 +5399,9 @@
           <a:p>
             <a:pPr algn="l">
               <a:lnSpc>
-                <a:spcPct val="140000"/>
+                <a:spcPct val="130000"/>
               </a:lnSpc>
-              <a:defRPr sz="1800" b="1">
+              <a:defRPr sz="1400" b="1">
                 <a:solidFill>
                   <a:srgbClr val="FFC947"/>
                 </a:solidFill>
@@ -5438,7 +5422,7 @@
         </p:nvSpPr>
         <p:spPr>
           <a:xfrm>
-            <a:off x="457200" y="2560320"/>
+            <a:off x="365760" y="2103120"/>
             <a:ext cx="320040" cy="320040"/>
           </a:xfrm>
           <a:prstGeom prst="roundRect">
@@ -5470,7 +5454,7 @@
           <a:lstStyle/>
           <a:p>
             <a:pPr algn="ctr">
-              <a:defRPr sz="1600" b="1">
+              <a:defRPr sz="1400" b="1">
                 <a:solidFill>
                   <a:srgbClr val="0A1931"/>
                 </a:solidFill>
@@ -5490,8 +5474,8 @@
         </p:nvSpPr>
         <p:spPr>
           <a:xfrm>
-            <a:off x="914400" y="2606039"/>
-            <a:ext cx="7315200" cy="365760"/>
+            <a:off x="822960" y="2148839"/>
+            <a:ext cx="7315200" cy="320040"/>
           </a:xfrm>
           <a:prstGeom prst="rect">
             <a:avLst/>
@@ -5506,9 +5490,9 @@
           <a:p>
             <a:pPr algn="l">
               <a:lnSpc>
-                <a:spcPct val="140000"/>
+                <a:spcPct val="130000"/>
               </a:lnSpc>
-              <a:defRPr sz="1800" b="0">
+              <a:defRPr sz="1600" b="0">
                 <a:solidFill>
                   <a:srgbClr val="F8FAFC"/>
                 </a:solidFill>
@@ -5529,7 +5513,7 @@
         </p:nvSpPr>
         <p:spPr>
           <a:xfrm>
-            <a:off x="457200" y="3154679"/>
+            <a:off x="365760" y="2606039"/>
             <a:ext cx="320040" cy="320040"/>
           </a:xfrm>
           <a:prstGeom prst="roundRect">
@@ -5561,7 +5545,7 @@
           <a:lstStyle/>
           <a:p>
             <a:pPr algn="ctr">
-              <a:defRPr sz="1600" b="1">
+              <a:defRPr sz="1400" b="1">
                 <a:solidFill>
                   <a:srgbClr val="0A1931"/>
                 </a:solidFill>
@@ -5581,8 +5565,8 @@
         </p:nvSpPr>
         <p:spPr>
           <a:xfrm>
-            <a:off x="914400" y="3200399"/>
-            <a:ext cx="7315200" cy="365760"/>
+            <a:off x="822960" y="2651759"/>
+            <a:ext cx="7315200" cy="320040"/>
           </a:xfrm>
           <a:prstGeom prst="rect">
             <a:avLst/>
@@ -5597,9 +5581,9 @@
           <a:p>
             <a:pPr algn="l">
               <a:lnSpc>
-                <a:spcPct val="140000"/>
+                <a:spcPct val="130000"/>
               </a:lnSpc>
-              <a:defRPr sz="1800" b="0">
+              <a:defRPr sz="1600" b="0">
                 <a:solidFill>
                   <a:srgbClr val="F8FAFC"/>
                 </a:solidFill>
@@ -5620,7 +5604,7 @@
         </p:nvSpPr>
         <p:spPr>
           <a:xfrm>
-            <a:off x="457200" y="3749039"/>
+            <a:off x="365760" y="3108959"/>
             <a:ext cx="320040" cy="320040"/>
           </a:xfrm>
           <a:prstGeom prst="roundRect">
@@ -5652,7 +5636,7 @@
           <a:lstStyle/>
           <a:p>
             <a:pPr algn="ctr">
-              <a:defRPr sz="1600" b="1">
+              <a:defRPr sz="1400" b="1">
                 <a:solidFill>
                   <a:srgbClr val="0A1931"/>
                 </a:solidFill>
@@ -5672,8 +5656,8 @@
         </p:nvSpPr>
         <p:spPr>
           <a:xfrm>
-            <a:off x="914400" y="3794759"/>
-            <a:ext cx="7315200" cy="365760"/>
+            <a:off x="822960" y="3154679"/>
+            <a:ext cx="7315200" cy="320040"/>
           </a:xfrm>
           <a:prstGeom prst="rect">
             <a:avLst/>
@@ -5688,9 +5672,9 @@
           <a:p>
             <a:pPr algn="l">
               <a:lnSpc>
-                <a:spcPct val="140000"/>
+                <a:spcPct val="130000"/>
               </a:lnSpc>
-              <a:defRPr sz="1800" b="0">
+              <a:defRPr sz="1600" b="0">
                 <a:solidFill>
                   <a:srgbClr val="F8FAFC"/>
                 </a:solidFill>
@@ -5711,8 +5695,8 @@
         </p:nvSpPr>
         <p:spPr>
           <a:xfrm>
-            <a:off x="457200" y="4572000"/>
-            <a:ext cx="8229600" cy="731520"/>
+            <a:off x="365760" y="3931920"/>
+            <a:ext cx="8229600" cy="548640"/>
           </a:xfrm>
           <a:prstGeom prst="rect">
             <a:avLst/>
@@ -5727,9 +5711,9 @@
           <a:p>
             <a:pPr algn="l">
               <a:lnSpc>
-                <a:spcPct val="140000"/>
+                <a:spcPct val="130000"/>
               </a:lnSpc>
-              <a:defRPr sz="4200" b="1">
+              <a:defRPr sz="3600" b="1">
                 <a:solidFill>
                   <a:srgbClr val="FFC947"/>
                 </a:solidFill>
@@ -5758,7 +5742,7 @@
         </p:blipFill>
         <p:spPr>
           <a:xfrm>
-            <a:off x="7589520" y="274320"/>
+            <a:off x="7589520" y="228600"/>
             <a:ext cx="1188720" cy="711889"/>
           </a:xfrm>
           <a:prstGeom prst="rect">
@@ -5774,7 +5758,7 @@
         </p:nvSpPr>
         <p:spPr>
           <a:xfrm>
-            <a:off x="0" y="6492240"/>
+            <a:off x="0" y="6446520"/>
             <a:ext cx="9144000" cy="25400"/>
           </a:xfrm>
           <a:prstGeom prst="rect">
@@ -5817,8 +5801,8 @@
         </p:nvSpPr>
         <p:spPr>
           <a:xfrm>
-            <a:off x="457200" y="6537960"/>
-            <a:ext cx="8229600" cy="274320"/>
+            <a:off x="365760" y="6510528"/>
+            <a:ext cx="8229600" cy="228600"/>
           </a:xfrm>
           <a:prstGeom prst="rect">
             <a:avLst/>
@@ -5879,8 +5863,8 @@
         </p:nvSpPr>
         <p:spPr>
           <a:xfrm>
-            <a:off x="457200" y="457200"/>
-            <a:ext cx="7315200" cy="365760"/>
+            <a:off x="365760" y="365760"/>
+            <a:ext cx="7315200" cy="274320"/>
           </a:xfrm>
           <a:prstGeom prst="rect">
             <a:avLst/>
@@ -5894,7 +5878,7 @@
           <a:lstStyle/>
           <a:p>
             <a:pPr>
-              <a:defRPr sz="1200" b="1">
+              <a:defRPr sz="1100" b="1">
                 <a:solidFill>
                   <a:srgbClr val="FFC947"/>
                 </a:solidFill>
@@ -5915,8 +5899,8 @@
         </p:nvSpPr>
         <p:spPr>
           <a:xfrm>
-            <a:off x="457200" y="822960"/>
-            <a:ext cx="7315200" cy="1097280"/>
+            <a:off x="365760" y="685800"/>
+            <a:ext cx="8229600" cy="822960"/>
           </a:xfrm>
           <a:prstGeom prst="rect">
             <a:avLst/>
@@ -5930,7 +5914,7 @@
           <a:lstStyle/>
           <a:p>
             <a:pPr>
-              <a:defRPr sz="3600" b="1">
+              <a:defRPr sz="3200" b="1">
                 <a:solidFill>
                   <a:srgbClr val="F8FAFC"/>
                 </a:solidFill>
@@ -5951,8 +5935,8 @@
         </p:nvSpPr>
         <p:spPr>
           <a:xfrm>
-            <a:off x="457200" y="2011680"/>
-            <a:ext cx="8229600" cy="365760"/>
+            <a:off x="365760" y="1645920"/>
+            <a:ext cx="8229600" cy="320040"/>
           </a:xfrm>
           <a:prstGeom prst="rect">
             <a:avLst/>
@@ -5967,9 +5951,9 @@
           <a:p>
             <a:pPr algn="l">
               <a:lnSpc>
-                <a:spcPct val="140000"/>
+                <a:spcPct val="130000"/>
               </a:lnSpc>
-              <a:defRPr sz="1600" b="1">
+              <a:defRPr sz="1400" b="1">
                 <a:solidFill>
                   <a:srgbClr val="FFC947"/>
                 </a:solidFill>
@@ -5990,8 +5974,8 @@
         </p:nvSpPr>
         <p:spPr>
           <a:xfrm>
-            <a:off x="457200" y="2560320"/>
-            <a:ext cx="502920" cy="502920"/>
+            <a:off x="365760" y="2103120"/>
+            <a:ext cx="411480" cy="411480"/>
           </a:xfrm>
           <a:prstGeom prst="ellipse">
             <a:avLst/>
@@ -6022,7 +6006,7 @@
           <a:lstStyle/>
           <a:p>
             <a:pPr algn="ctr">
-              <a:defRPr sz="1800" b="1">
+              <a:defRPr sz="1600" b="1">
                 <a:solidFill>
                   <a:srgbClr val="0A1931"/>
                 </a:solidFill>
@@ -6042,8 +6026,8 @@
         </p:nvSpPr>
         <p:spPr>
           <a:xfrm>
-            <a:off x="1097280" y="2651760"/>
-            <a:ext cx="7315200" cy="457200"/>
+            <a:off x="914400" y="2176272"/>
+            <a:ext cx="7315200" cy="365760"/>
           </a:xfrm>
           <a:prstGeom prst="rect">
             <a:avLst/>
@@ -6058,9 +6042,9 @@
           <a:p>
             <a:pPr algn="l">
               <a:lnSpc>
-                <a:spcPct val="140000"/>
+                <a:spcPct val="130000"/>
               </a:lnSpc>
-              <a:defRPr sz="1700" b="0">
+              <a:defRPr sz="1400" b="0">
                 <a:solidFill>
                   <a:srgbClr val="F8FAFC"/>
                 </a:solidFill>
@@ -6081,8 +6065,8 @@
         </p:nvSpPr>
         <p:spPr>
           <a:xfrm>
-            <a:off x="457200" y="3200400"/>
-            <a:ext cx="502920" cy="502920"/>
+            <a:off x="365760" y="2651760"/>
+            <a:ext cx="411480" cy="411480"/>
           </a:xfrm>
           <a:prstGeom prst="ellipse">
             <a:avLst/>
@@ -6113,7 +6097,7 @@
           <a:lstStyle/>
           <a:p>
             <a:pPr algn="ctr">
-              <a:defRPr sz="1800" b="1">
+              <a:defRPr sz="1600" b="1">
                 <a:solidFill>
                   <a:srgbClr val="0A1931"/>
                 </a:solidFill>
@@ -6133,8 +6117,8 @@
         </p:nvSpPr>
         <p:spPr>
           <a:xfrm>
-            <a:off x="1097280" y="3291840"/>
-            <a:ext cx="7315200" cy="457200"/>
+            <a:off x="914400" y="2724912"/>
+            <a:ext cx="7315200" cy="365760"/>
           </a:xfrm>
           <a:prstGeom prst="rect">
             <a:avLst/>
@@ -6149,9 +6133,9 @@
           <a:p>
             <a:pPr algn="l">
               <a:lnSpc>
-                <a:spcPct val="140000"/>
+                <a:spcPct val="130000"/>
               </a:lnSpc>
-              <a:defRPr sz="1700" b="0">
+              <a:defRPr sz="1400" b="0">
                 <a:solidFill>
                   <a:srgbClr val="F8FAFC"/>
                 </a:solidFill>
@@ -6172,8 +6156,8 @@
         </p:nvSpPr>
         <p:spPr>
           <a:xfrm>
-            <a:off x="457200" y="3840480"/>
-            <a:ext cx="502920" cy="502920"/>
+            <a:off x="365760" y="3200400"/>
+            <a:ext cx="411480" cy="411480"/>
           </a:xfrm>
           <a:prstGeom prst="ellipse">
             <a:avLst/>
@@ -6204,7 +6188,7 @@
           <a:lstStyle/>
           <a:p>
             <a:pPr algn="ctr">
-              <a:defRPr sz="1800" b="1">
+              <a:defRPr sz="1600" b="1">
                 <a:solidFill>
                   <a:srgbClr val="0A1931"/>
                 </a:solidFill>
@@ -6224,8 +6208,8 @@
         </p:nvSpPr>
         <p:spPr>
           <a:xfrm>
-            <a:off x="1097280" y="3931920"/>
-            <a:ext cx="7315200" cy="457200"/>
+            <a:off x="914400" y="3273552"/>
+            <a:ext cx="7315200" cy="365760"/>
           </a:xfrm>
           <a:prstGeom prst="rect">
             <a:avLst/>
@@ -6240,9 +6224,9 @@
           <a:p>
             <a:pPr algn="l">
               <a:lnSpc>
-                <a:spcPct val="140000"/>
+                <a:spcPct val="130000"/>
               </a:lnSpc>
-              <a:defRPr sz="1700" b="0">
+              <a:defRPr sz="1400" b="0">
                 <a:solidFill>
                   <a:srgbClr val="F8FAFC"/>
                 </a:solidFill>
@@ -6263,8 +6247,8 @@
         </p:nvSpPr>
         <p:spPr>
           <a:xfrm>
-            <a:off x="457200" y="4480560"/>
-            <a:ext cx="502920" cy="502920"/>
+            <a:off x="365760" y="3749039"/>
+            <a:ext cx="411480" cy="411480"/>
           </a:xfrm>
           <a:prstGeom prst="ellipse">
             <a:avLst/>
@@ -6295,7 +6279,7 @@
           <a:lstStyle/>
           <a:p>
             <a:pPr algn="ctr">
-              <a:defRPr sz="1800" b="1">
+              <a:defRPr sz="1600" b="1">
                 <a:solidFill>
                   <a:srgbClr val="0A1931"/>
                 </a:solidFill>
@@ -6315,8 +6299,8 @@
         </p:nvSpPr>
         <p:spPr>
           <a:xfrm>
-            <a:off x="1097280" y="4572000"/>
-            <a:ext cx="7315200" cy="457200"/>
+            <a:off x="914400" y="3822191"/>
+            <a:ext cx="7315200" cy="365760"/>
           </a:xfrm>
           <a:prstGeom prst="rect">
             <a:avLst/>
@@ -6331,9 +6315,9 @@
           <a:p>
             <a:pPr algn="l">
               <a:lnSpc>
-                <a:spcPct val="140000"/>
+                <a:spcPct val="130000"/>
               </a:lnSpc>
-              <a:defRPr sz="1700" b="0">
+              <a:defRPr sz="1400" b="0">
                 <a:solidFill>
                   <a:srgbClr val="F8FAFC"/>
                 </a:solidFill>
@@ -6362,7 +6346,7 @@
         </p:blipFill>
         <p:spPr>
           <a:xfrm>
-            <a:off x="7589520" y="274320"/>
+            <a:off x="7589520" y="228600"/>
             <a:ext cx="1188720" cy="711889"/>
           </a:xfrm>
           <a:prstGeom prst="rect">
@@ -6378,7 +6362,7 @@
         </p:nvSpPr>
         <p:spPr>
           <a:xfrm>
-            <a:off x="0" y="6492240"/>
+            <a:off x="0" y="6446520"/>
             <a:ext cx="9144000" cy="25400"/>
           </a:xfrm>
           <a:prstGeom prst="rect">
@@ -6421,8 +6405,8 @@
         </p:nvSpPr>
         <p:spPr>
           <a:xfrm>
-            <a:off x="457200" y="6537960"/>
-            <a:ext cx="8229600" cy="274320"/>
+            <a:off x="365760" y="6510528"/>
+            <a:ext cx="8229600" cy="228600"/>
           </a:xfrm>
           <a:prstGeom prst="rect">
             <a:avLst/>
@@ -6483,8 +6467,8 @@
         </p:nvSpPr>
         <p:spPr>
           <a:xfrm>
-            <a:off x="457200" y="457200"/>
-            <a:ext cx="7315200" cy="365760"/>
+            <a:off x="365760" y="365760"/>
+            <a:ext cx="7315200" cy="274320"/>
           </a:xfrm>
           <a:prstGeom prst="rect">
             <a:avLst/>
@@ -6498,7 +6482,7 @@
           <a:lstStyle/>
           <a:p>
             <a:pPr>
-              <a:defRPr sz="1200" b="1">
+              <a:defRPr sz="1100" b="1">
                 <a:solidFill>
                   <a:srgbClr val="FFC947"/>
                 </a:solidFill>
@@ -6519,8 +6503,8 @@
         </p:nvSpPr>
         <p:spPr>
           <a:xfrm>
-            <a:off x="457200" y="822960"/>
-            <a:ext cx="7315200" cy="1097280"/>
+            <a:off x="365760" y="685800"/>
+            <a:ext cx="8229600" cy="822960"/>
           </a:xfrm>
           <a:prstGeom prst="rect">
             <a:avLst/>
@@ -6534,7 +6518,7 @@
           <a:lstStyle/>
           <a:p>
             <a:pPr>
-              <a:defRPr sz="3000" b="1">
+              <a:defRPr sz="3200" b="1">
                 <a:solidFill>
                   <a:srgbClr val="F8FAFC"/>
                 </a:solidFill>
@@ -6542,11 +6526,7 @@
               </a:defRPr>
             </a:pPr>
             <a:r>
-              <a:t>Wenn Daten Betriebsgeheimnis sind,</a:t>
-            </a:r>
-            <a:br/>
-            <a:r>
-              <a:t>wird das mitgedacht</a:t>
+              <a:t>Wenn Daten Betriebsgeheimnis sind, wird das mitgedacht</a:t>
             </a:r>
           </a:p>
         </p:txBody>
@@ -6559,8 +6539,8 @@
         </p:nvSpPr>
         <p:spPr>
           <a:xfrm>
-            <a:off x="457200" y="2194560"/>
-            <a:ext cx="2651760" cy="914400"/>
+            <a:off x="365760" y="1737360"/>
+            <a:ext cx="2697480" cy="868680"/>
           </a:xfrm>
           <a:prstGeom prst="roundRect">
             <a:avLst/>
@@ -6604,8 +6584,8 @@
         </p:nvSpPr>
         <p:spPr>
           <a:xfrm>
-            <a:off x="594360" y="2286000"/>
-            <a:ext cx="2377440" cy="320040"/>
+            <a:off x="457200" y="1828800"/>
+            <a:ext cx="2514600" cy="274320"/>
           </a:xfrm>
           <a:prstGeom prst="rect">
             <a:avLst/>
@@ -6620,9 +6600,9 @@
           <a:p>
             <a:pPr algn="l">
               <a:lnSpc>
-                <a:spcPct val="140000"/>
+                <a:spcPct val="130000"/>
               </a:lnSpc>
-              <a:defRPr sz="1300" b="1">
+              <a:defRPr sz="1400" b="1">
                 <a:solidFill>
                   <a:srgbClr val="FFC947"/>
                 </a:solidFill>
@@ -6643,8 +6623,8 @@
         </p:nvSpPr>
         <p:spPr>
           <a:xfrm>
-            <a:off x="594360" y="2606040"/>
-            <a:ext cx="2377440" cy="365760"/>
+            <a:off x="457200" y="2148840"/>
+            <a:ext cx="2514600" cy="274320"/>
           </a:xfrm>
           <a:prstGeom prst="rect">
             <a:avLst/>
@@ -6659,7 +6639,7 @@
           <a:p>
             <a:pPr algn="l">
               <a:lnSpc>
-                <a:spcPct val="140000"/>
+                <a:spcPct val="130000"/>
               </a:lnSpc>
               <a:defRPr sz="1100" b="0">
                 <a:solidFill>
@@ -6682,8 +6662,8 @@
         </p:nvSpPr>
         <p:spPr>
           <a:xfrm>
-            <a:off x="3246120" y="2194560"/>
-            <a:ext cx="2651760" cy="914400"/>
+            <a:off x="3200400" y="1737360"/>
+            <a:ext cx="2697480" cy="868680"/>
           </a:xfrm>
           <a:prstGeom prst="roundRect">
             <a:avLst/>
@@ -6727,8 +6707,8 @@
         </p:nvSpPr>
         <p:spPr>
           <a:xfrm>
-            <a:off x="3383279" y="2286000"/>
-            <a:ext cx="2377440" cy="320040"/>
+            <a:off x="3291840" y="1828800"/>
+            <a:ext cx="2514600" cy="274320"/>
           </a:xfrm>
           <a:prstGeom prst="rect">
             <a:avLst/>
@@ -6743,9 +6723,9 @@
           <a:p>
             <a:pPr algn="l">
               <a:lnSpc>
-                <a:spcPct val="140000"/>
+                <a:spcPct val="130000"/>
               </a:lnSpc>
-              <a:defRPr sz="1300" b="1">
+              <a:defRPr sz="1400" b="1">
                 <a:solidFill>
                   <a:srgbClr val="FFC947"/>
                 </a:solidFill>
@@ -6766,8 +6746,8 @@
         </p:nvSpPr>
         <p:spPr>
           <a:xfrm>
-            <a:off x="3383279" y="2606040"/>
-            <a:ext cx="2377440" cy="365760"/>
+            <a:off x="3291840" y="2148840"/>
+            <a:ext cx="2514600" cy="274320"/>
           </a:xfrm>
           <a:prstGeom prst="rect">
             <a:avLst/>
@@ -6782,7 +6762,7 @@
           <a:p>
             <a:pPr algn="l">
               <a:lnSpc>
-                <a:spcPct val="140000"/>
+                <a:spcPct val="130000"/>
               </a:lnSpc>
               <a:defRPr sz="1100" b="0">
                 <a:solidFill>
@@ -6805,8 +6785,8 @@
         </p:nvSpPr>
         <p:spPr>
           <a:xfrm>
-            <a:off x="6035040" y="2194560"/>
-            <a:ext cx="2651760" cy="914400"/>
+            <a:off x="6035040" y="1737360"/>
+            <a:ext cx="2697480" cy="868680"/>
           </a:xfrm>
           <a:prstGeom prst="roundRect">
             <a:avLst/>
@@ -6850,8 +6830,8 @@
         </p:nvSpPr>
         <p:spPr>
           <a:xfrm>
-            <a:off x="6172200" y="2286000"/>
-            <a:ext cx="2377440" cy="320040"/>
+            <a:off x="6126479" y="1828800"/>
+            <a:ext cx="2514600" cy="274320"/>
           </a:xfrm>
           <a:prstGeom prst="rect">
             <a:avLst/>
@@ -6866,9 +6846,9 @@
           <a:p>
             <a:pPr algn="l">
               <a:lnSpc>
-                <a:spcPct val="140000"/>
+                <a:spcPct val="130000"/>
               </a:lnSpc>
-              <a:defRPr sz="1300" b="1">
+              <a:defRPr sz="1400" b="1">
                 <a:solidFill>
                   <a:srgbClr val="FFC947"/>
                 </a:solidFill>
@@ -6889,8 +6869,8 @@
         </p:nvSpPr>
         <p:spPr>
           <a:xfrm>
-            <a:off x="6172200" y="2606040"/>
-            <a:ext cx="2377440" cy="365760"/>
+            <a:off x="6126479" y="2148840"/>
+            <a:ext cx="2514600" cy="274320"/>
           </a:xfrm>
           <a:prstGeom prst="rect">
             <a:avLst/>
@@ -6905,7 +6885,7 @@
           <a:p>
             <a:pPr algn="l">
               <a:lnSpc>
-                <a:spcPct val="140000"/>
+                <a:spcPct val="130000"/>
               </a:lnSpc>
               <a:defRPr sz="1100" b="0">
                 <a:solidFill>
@@ -6915,7 +6895,7 @@
               </a:defRPr>
             </a:pPr>
             <a:r>
-              <a:t>Sichtbar welche Quellen genutzt werden</a:t>
+              <a:t>Quellen sind sichtbar</a:t>
             </a:r>
           </a:p>
         </p:txBody>
@@ -6928,8 +6908,8 @@
         </p:nvSpPr>
         <p:spPr>
           <a:xfrm>
-            <a:off x="1828800" y="3383280"/>
-            <a:ext cx="2651760" cy="914400"/>
+            <a:off x="1828800" y="2834640"/>
+            <a:ext cx="2697480" cy="868680"/>
           </a:xfrm>
           <a:prstGeom prst="roundRect">
             <a:avLst/>
@@ -6973,8 +6953,8 @@
         </p:nvSpPr>
         <p:spPr>
           <a:xfrm>
-            <a:off x="1965960" y="3474720"/>
-            <a:ext cx="2377440" cy="320040"/>
+            <a:off x="1920240" y="2926080"/>
+            <a:ext cx="2514600" cy="274320"/>
           </a:xfrm>
           <a:prstGeom prst="rect">
             <a:avLst/>
@@ -6989,9 +6969,9 @@
           <a:p>
             <a:pPr algn="l">
               <a:lnSpc>
-                <a:spcPct val="140000"/>
+                <a:spcPct val="130000"/>
               </a:lnSpc>
-              <a:defRPr sz="1300" b="1">
+              <a:defRPr sz="1400" b="1">
                 <a:solidFill>
                   <a:srgbClr val="FFC947"/>
                 </a:solidFill>
@@ -7012,8 +6992,8 @@
         </p:nvSpPr>
         <p:spPr>
           <a:xfrm>
-            <a:off x="1965960" y="3794760"/>
-            <a:ext cx="2377440" cy="365760"/>
+            <a:off x="1920240" y="3246120"/>
+            <a:ext cx="2514600" cy="274320"/>
           </a:xfrm>
           <a:prstGeom prst="rect">
             <a:avLst/>
@@ -7028,7 +7008,7 @@
           <a:p>
             <a:pPr algn="l">
               <a:lnSpc>
-                <a:spcPct val="140000"/>
+                <a:spcPct val="130000"/>
               </a:lnSpc>
               <a:defRPr sz="1100" b="0">
                 <a:solidFill>
@@ -7051,8 +7031,8 @@
         </p:nvSpPr>
         <p:spPr>
           <a:xfrm>
-            <a:off x="4663440" y="3383280"/>
-            <a:ext cx="2651760" cy="914400"/>
+            <a:off x="4663440" y="2834640"/>
+            <a:ext cx="2697480" cy="868680"/>
           </a:xfrm>
           <a:prstGeom prst="roundRect">
             <a:avLst/>
@@ -7096,8 +7076,8 @@
         </p:nvSpPr>
         <p:spPr>
           <a:xfrm>
-            <a:off x="4800600" y="3474720"/>
-            <a:ext cx="2377440" cy="320040"/>
+            <a:off x="4754879" y="2926080"/>
+            <a:ext cx="2514600" cy="274320"/>
           </a:xfrm>
           <a:prstGeom prst="rect">
             <a:avLst/>
@@ -7112,9 +7092,9 @@
           <a:p>
             <a:pPr algn="l">
               <a:lnSpc>
-                <a:spcPct val="140000"/>
+                <a:spcPct val="130000"/>
               </a:lnSpc>
-              <a:defRPr sz="1300" b="1">
+              <a:defRPr sz="1400" b="1">
                 <a:solidFill>
                   <a:srgbClr val="FFC947"/>
                 </a:solidFill>
@@ -7135,8 +7115,8 @@
         </p:nvSpPr>
         <p:spPr>
           <a:xfrm>
-            <a:off x="4800600" y="3794760"/>
-            <a:ext cx="2377440" cy="365760"/>
+            <a:off x="4754879" y="3246120"/>
+            <a:ext cx="2514600" cy="274320"/>
           </a:xfrm>
           <a:prstGeom prst="rect">
             <a:avLst/>
@@ -7151,7 +7131,7 @@
           <a:p>
             <a:pPr algn="l">
               <a:lnSpc>
-                <a:spcPct val="140000"/>
+                <a:spcPct val="130000"/>
               </a:lnSpc>
               <a:defRPr sz="1100" b="0">
                 <a:solidFill>
@@ -7174,12 +7154,12 @@
         </p:nvSpPr>
         <p:spPr>
           <a:xfrm>
-            <a:off x="457200" y="4663440"/>
-            <a:ext cx="8229600" cy="777240"/>
+            <a:off x="365760" y="4023360"/>
+            <a:ext cx="8412480" cy="914400"/>
           </a:xfrm>
           <a:prstGeom prst="roundRect">
             <a:avLst>
-              <a:gd name="adj" fmla="val 10000"/>
+              <a:gd name="adj" fmla="val 8000"/>
             </a:avLst>
           </a:prstGeom>
           <a:solidFill>
@@ -7209,9 +7189,9 @@
           <a:p>
             <a:pPr algn="ctr">
               <a:lnSpc>
-                <a:spcPct val="130000"/>
+                <a:spcPct val="120000"/>
               </a:lnSpc>
-              <a:defRPr sz="1800" b="1">
+              <a:defRPr sz="1700" b="1">
                 <a:solidFill>
                   <a:srgbClr val="0A1931"/>
                 </a:solidFill>
@@ -7240,7 +7220,7 @@
         </p:blipFill>
         <p:spPr>
           <a:xfrm>
-            <a:off x="7589520" y="274320"/>
+            <a:off x="7589520" y="228600"/>
             <a:ext cx="1188720" cy="711889"/>
           </a:xfrm>
           <a:prstGeom prst="rect">
@@ -7256,7 +7236,7 @@
         </p:nvSpPr>
         <p:spPr>
           <a:xfrm>
-            <a:off x="0" y="6492240"/>
+            <a:off x="0" y="6446520"/>
             <a:ext cx="9144000" cy="25400"/>
           </a:xfrm>
           <a:prstGeom prst="rect">
@@ -7299,8 +7279,8 @@
         </p:nvSpPr>
         <p:spPr>
           <a:xfrm>
-            <a:off x="457200" y="6537960"/>
-            <a:ext cx="8229600" cy="274320"/>
+            <a:off x="365760" y="6510528"/>
+            <a:ext cx="8229600" cy="228600"/>
           </a:xfrm>
           <a:prstGeom prst="rect">
             <a:avLst/>
@@ -7361,8 +7341,8 @@
         </p:nvSpPr>
         <p:spPr>
           <a:xfrm>
-            <a:off x="0" y="2286000"/>
-            <a:ext cx="137160" cy="1828800"/>
+            <a:off x="0" y="2011680"/>
+            <a:ext cx="109728" cy="1828800"/>
           </a:xfrm>
           <a:prstGeom prst="rect">
             <a:avLst/>
@@ -7404,8 +7384,8 @@
         </p:nvSpPr>
         <p:spPr>
           <a:xfrm>
-            <a:off x="731520" y="1645920"/>
-            <a:ext cx="7315200" cy="548640"/>
+            <a:off x="548640" y="1371600"/>
+            <a:ext cx="7315200" cy="457200"/>
           </a:xfrm>
           <a:prstGeom prst="rect">
             <a:avLst/>
@@ -7420,9 +7400,9 @@
           <a:p>
             <a:pPr algn="l">
               <a:lnSpc>
-                <a:spcPct val="140000"/>
+                <a:spcPct val="130000"/>
               </a:lnSpc>
-              <a:defRPr sz="2400" b="0">
+              <a:defRPr sz="2200" b="0">
                 <a:solidFill>
                   <a:srgbClr val="CBD5E1"/>
                 </a:solidFill>
@@ -7443,7 +7423,7 @@
         </p:nvSpPr>
         <p:spPr>
           <a:xfrm>
-            <a:off x="731520" y="2286000"/>
+            <a:off x="548640" y="2011680"/>
             <a:ext cx="7315200" cy="1371600"/>
           </a:xfrm>
           <a:prstGeom prst="rect">
@@ -7459,9 +7439,9 @@
           <a:p>
             <a:pPr algn="l">
               <a:lnSpc>
-                <a:spcPct val="140000"/>
+                <a:spcPct val="130000"/>
               </a:lnSpc>
-              <a:defRPr sz="3200" b="1">
+              <a:defRPr sz="2800" b="1">
                 <a:solidFill>
                   <a:srgbClr val="FFC947"/>
                 </a:solidFill>
@@ -7490,8 +7470,8 @@
         </p:nvSpPr>
         <p:spPr>
           <a:xfrm>
-            <a:off x="457200" y="4572000"/>
-            <a:ext cx="3657600" cy="1371600"/>
+            <a:off x="365760" y="4206240"/>
+            <a:ext cx="3657600" cy="1463040"/>
           </a:xfrm>
           <a:prstGeom prst="roundRect">
             <a:avLst/>
@@ -7535,8 +7515,8 @@
         </p:nvSpPr>
         <p:spPr>
           <a:xfrm>
-            <a:off x="640080" y="4663440"/>
-            <a:ext cx="3200400" cy="274320"/>
+            <a:off x="502920" y="4297680"/>
+            <a:ext cx="3200400" cy="228600"/>
           </a:xfrm>
           <a:prstGeom prst="rect">
             <a:avLst/>
@@ -7551,9 +7531,9 @@
           <a:p>
             <a:pPr algn="l">
               <a:lnSpc>
-                <a:spcPct val="140000"/>
+                <a:spcPct val="130000"/>
               </a:lnSpc>
-              <a:defRPr sz="1200" b="1">
+              <a:defRPr sz="1100" b="1">
                 <a:solidFill>
                   <a:srgbClr val="FFC947"/>
                 </a:solidFill>
@@ -7574,8 +7554,8 @@
         </p:nvSpPr>
         <p:spPr>
           <a:xfrm>
-            <a:off x="640080" y="4937760"/>
-            <a:ext cx="3200400" cy="320040"/>
+            <a:off x="502920" y="4572000"/>
+            <a:ext cx="3200400" cy="274320"/>
           </a:xfrm>
           <a:prstGeom prst="rect">
             <a:avLst/>
@@ -7590,9 +7570,9 @@
           <a:p>
             <a:pPr algn="l">
               <a:lnSpc>
-                <a:spcPct val="140000"/>
+                <a:spcPct val="130000"/>
               </a:lnSpc>
-              <a:defRPr sz="1800" b="1">
+              <a:defRPr sz="1600" b="1">
                 <a:solidFill>
                   <a:srgbClr val="F8FAFC"/>
                 </a:solidFill>
@@ -7613,8 +7593,8 @@
         </p:nvSpPr>
         <p:spPr>
           <a:xfrm>
-            <a:off x="640080" y="5257800"/>
-            <a:ext cx="3200400" cy="274320"/>
+            <a:off x="502920" y="4892040"/>
+            <a:ext cx="3200400" cy="228600"/>
           </a:xfrm>
           <a:prstGeom prst="rect">
             <a:avLst/>
@@ -7629,7 +7609,7 @@
           <a:p>
             <a:pPr algn="l">
               <a:lnSpc>
-                <a:spcPct val="140000"/>
+                <a:spcPct val="130000"/>
               </a:lnSpc>
               <a:defRPr sz="1400" b="0">
                 <a:solidFill>
@@ -7652,8 +7632,8 @@
         </p:nvSpPr>
         <p:spPr>
           <a:xfrm>
-            <a:off x="640080" y="5532120"/>
-            <a:ext cx="3200400" cy="274320"/>
+            <a:off x="502920" y="5166360"/>
+            <a:ext cx="3200400" cy="228600"/>
           </a:xfrm>
           <a:prstGeom prst="rect">
             <a:avLst/>
@@ -7668,9 +7648,9 @@
           <a:p>
             <a:pPr algn="l">
               <a:lnSpc>
-                <a:spcPct val="140000"/>
+                <a:spcPct val="130000"/>
               </a:lnSpc>
-              <a:defRPr sz="1300" b="0">
+              <a:defRPr sz="1400" b="0">
                 <a:solidFill>
                   <a:srgbClr val="CBD5E1"/>
                 </a:solidFill>
@@ -7699,8 +7679,8 @@
         </p:blipFill>
         <p:spPr>
           <a:xfrm>
-            <a:off x="5486400" y="3931920"/>
-            <a:ext cx="3200400" cy="1916624"/>
+            <a:off x="5029200" y="3474720"/>
+            <a:ext cx="3657600" cy="2190427"/>
           </a:xfrm>
           <a:prstGeom prst="rect">
             <a:avLst/>
@@ -7715,7 +7695,7 @@
         </p:nvSpPr>
         <p:spPr>
           <a:xfrm>
-            <a:off x="0" y="6492240"/>
+            <a:off x="0" y="6446520"/>
             <a:ext cx="9144000" cy="25400"/>
           </a:xfrm>
           <a:prstGeom prst="rect">
@@ -7758,8 +7738,8 @@
         </p:nvSpPr>
         <p:spPr>
           <a:xfrm>
-            <a:off x="457200" y="6537960"/>
-            <a:ext cx="8229600" cy="274320"/>
+            <a:off x="365760" y="6510528"/>
+            <a:ext cx="8229600" cy="228600"/>
           </a:xfrm>
           <a:prstGeom prst="rect">
             <a:avLst/>
@@ -7820,8 +7800,8 @@
         </p:nvSpPr>
         <p:spPr>
           <a:xfrm>
-            <a:off x="457200" y="457200"/>
-            <a:ext cx="7315200" cy="365760"/>
+            <a:off x="365760" y="365760"/>
+            <a:ext cx="7315200" cy="274320"/>
           </a:xfrm>
           <a:prstGeom prst="rect">
             <a:avLst/>
@@ -7835,7 +7815,7 @@
           <a:lstStyle/>
           <a:p>
             <a:pPr>
-              <a:defRPr sz="1200" b="1">
+              <a:defRPr sz="1100" b="1">
                 <a:solidFill>
                   <a:srgbClr val="FFC947"/>
                 </a:solidFill>
@@ -7856,8 +7836,8 @@
         </p:nvSpPr>
         <p:spPr>
           <a:xfrm>
-            <a:off x="457200" y="822960"/>
-            <a:ext cx="7315200" cy="1097280"/>
+            <a:off x="365760" y="685800"/>
+            <a:ext cx="8229600" cy="822960"/>
           </a:xfrm>
           <a:prstGeom prst="rect">
             <a:avLst/>
@@ -7871,7 +7851,7 @@
           <a:lstStyle/>
           <a:p>
             <a:pPr>
-              <a:defRPr sz="3600" b="1">
+              <a:defRPr sz="3200" b="1">
                 <a:solidFill>
                   <a:srgbClr val="F8FAFC"/>
                 </a:solidFill>
@@ -7892,8 +7872,8 @@
         </p:nvSpPr>
         <p:spPr>
           <a:xfrm>
-            <a:off x="457200" y="1920240"/>
-            <a:ext cx="3931920" cy="2286000"/>
+            <a:off x="365760" y="1645920"/>
+            <a:ext cx="4023360" cy="2560320"/>
           </a:xfrm>
           <a:prstGeom prst="roundRect">
             <a:avLst/>
@@ -7937,8 +7917,8 @@
         </p:nvSpPr>
         <p:spPr>
           <a:xfrm>
-            <a:off x="640080" y="2057400"/>
-            <a:ext cx="3566160" cy="365760"/>
+            <a:off x="502920" y="1755648"/>
+            <a:ext cx="3749040" cy="320040"/>
           </a:xfrm>
           <a:prstGeom prst="rect">
             <a:avLst/>
@@ -7953,7 +7933,7 @@
           <a:p>
             <a:pPr algn="l">
               <a:lnSpc>
-                <a:spcPct val="140000"/>
+                <a:spcPct val="130000"/>
               </a:lnSpc>
               <a:defRPr sz="1400" b="1">
                 <a:solidFill>
@@ -7976,8 +7956,8 @@
         </p:nvSpPr>
         <p:spPr>
           <a:xfrm>
-            <a:off x="640080" y="2377440"/>
-            <a:ext cx="3566160" cy="1737360"/>
+            <a:off x="502920" y="2057400"/>
+            <a:ext cx="3749040" cy="2057400"/>
           </a:xfrm>
           <a:prstGeom prst="rect">
             <a:avLst/>
@@ -7992,12 +7972,12 @@
           <a:p>
             <a:pPr>
               <a:lnSpc>
-                <a:spcPct val="160000"/>
+                <a:spcPct val="150000"/>
               </a:lnSpc>
               <a:spcAft>
-                <a:spcPts val="600"/>
+                <a:spcPts val="400"/>
               </a:spcAft>
-              <a:defRPr sz="1300">
+              <a:defRPr sz="1400">
                 <a:solidFill>
                   <a:srgbClr val="CBD5E1"/>
                 </a:solidFill>
@@ -8011,12 +7991,12 @@
           <a:p>
             <a:pPr>
               <a:lnSpc>
-                <a:spcPct val="160000"/>
+                <a:spcPct val="150000"/>
               </a:lnSpc>
               <a:spcAft>
-                <a:spcPts val="600"/>
+                <a:spcPts val="400"/>
               </a:spcAft>
-              <a:defRPr sz="1300">
+              <a:defRPr sz="1400">
                 <a:solidFill>
                   <a:srgbClr val="CBD5E1"/>
                 </a:solidFill>
@@ -8030,12 +8010,12 @@
           <a:p>
             <a:pPr>
               <a:lnSpc>
-                <a:spcPct val="160000"/>
+                <a:spcPct val="150000"/>
               </a:lnSpc>
               <a:spcAft>
-                <a:spcPts val="600"/>
+                <a:spcPts val="400"/>
               </a:spcAft>
-              <a:defRPr sz="1300">
+              <a:defRPr sz="1400">
                 <a:solidFill>
                   <a:srgbClr val="CBD5E1"/>
                 </a:solidFill>
@@ -8049,12 +8029,12 @@
           <a:p>
             <a:pPr>
               <a:lnSpc>
-                <a:spcPct val="160000"/>
+                <a:spcPct val="150000"/>
               </a:lnSpc>
               <a:spcAft>
-                <a:spcPts val="600"/>
+                <a:spcPts val="400"/>
               </a:spcAft>
-              <a:defRPr sz="1300">
+              <a:defRPr sz="1400">
                 <a:solidFill>
                   <a:srgbClr val="CBD5E1"/>
                 </a:solidFill>
@@ -8068,12 +8048,12 @@
           <a:p>
             <a:pPr>
               <a:lnSpc>
-                <a:spcPct val="160000"/>
+                <a:spcPct val="150000"/>
               </a:lnSpc>
               <a:spcAft>
-                <a:spcPts val="600"/>
+                <a:spcPts val="400"/>
               </a:spcAft>
-              <a:defRPr sz="1300">
+              <a:defRPr sz="1400">
                 <a:solidFill>
                   <a:srgbClr val="CBD5E1"/>
                 </a:solidFill>
@@ -8094,8 +8074,8 @@
         </p:nvSpPr>
         <p:spPr>
           <a:xfrm>
-            <a:off x="4754880" y="1920240"/>
-            <a:ext cx="3931920" cy="2286000"/>
+            <a:off x="4754880" y="1645920"/>
+            <a:ext cx="4023360" cy="2560320"/>
           </a:xfrm>
           <a:prstGeom prst="roundRect">
             <a:avLst/>
@@ -8139,8 +8119,8 @@
         </p:nvSpPr>
         <p:spPr>
           <a:xfrm>
-            <a:off x="4937760" y="2057400"/>
-            <a:ext cx="3566160" cy="365760"/>
+            <a:off x="4892040" y="1755648"/>
+            <a:ext cx="3749040" cy="320040"/>
           </a:xfrm>
           <a:prstGeom prst="rect">
             <a:avLst/>
@@ -8155,7 +8135,7 @@
           <a:p>
             <a:pPr algn="l">
               <a:lnSpc>
-                <a:spcPct val="140000"/>
+                <a:spcPct val="130000"/>
               </a:lnSpc>
               <a:defRPr sz="1400" b="1">
                 <a:solidFill>
@@ -8178,8 +8158,8 @@
         </p:nvSpPr>
         <p:spPr>
           <a:xfrm>
-            <a:off x="4937760" y="2377440"/>
-            <a:ext cx="3566160" cy="1737360"/>
+            <a:off x="4892040" y="2057400"/>
+            <a:ext cx="3749040" cy="2057400"/>
           </a:xfrm>
           <a:prstGeom prst="rect">
             <a:avLst/>
@@ -8194,12 +8174,12 @@
           <a:p>
             <a:pPr>
               <a:lnSpc>
-                <a:spcPct val="160000"/>
+                <a:spcPct val="150000"/>
               </a:lnSpc>
               <a:spcAft>
-                <a:spcPts val="600"/>
+                <a:spcPts val="400"/>
               </a:spcAft>
-              <a:defRPr sz="1300">
+              <a:defRPr sz="1400">
                 <a:solidFill>
                   <a:srgbClr val="CBD5E1"/>
                 </a:solidFill>
@@ -8213,12 +8193,12 @@
           <a:p>
             <a:pPr>
               <a:lnSpc>
-                <a:spcPct val="160000"/>
+                <a:spcPct val="150000"/>
               </a:lnSpc>
               <a:spcAft>
-                <a:spcPts val="600"/>
+                <a:spcPts val="400"/>
               </a:spcAft>
-              <a:defRPr sz="1300">
+              <a:defRPr sz="1400">
                 <a:solidFill>
                   <a:srgbClr val="CBD5E1"/>
                 </a:solidFill>
@@ -8232,12 +8212,12 @@
           <a:p>
             <a:pPr>
               <a:lnSpc>
-                <a:spcPct val="160000"/>
+                <a:spcPct val="150000"/>
               </a:lnSpc>
               <a:spcAft>
-                <a:spcPts val="600"/>
+                <a:spcPts val="400"/>
               </a:spcAft>
-              <a:defRPr sz="1300">
+              <a:defRPr sz="1400">
                 <a:solidFill>
                   <a:srgbClr val="CBD5E1"/>
                 </a:solidFill>
@@ -8251,12 +8231,12 @@
           <a:p>
             <a:pPr>
               <a:lnSpc>
-                <a:spcPct val="160000"/>
+                <a:spcPct val="150000"/>
               </a:lnSpc>
               <a:spcAft>
-                <a:spcPts val="600"/>
+                <a:spcPts val="400"/>
               </a:spcAft>
-              <a:defRPr sz="1300">
+              <a:defRPr sz="1400">
                 <a:solidFill>
                   <a:srgbClr val="CBD5E1"/>
                 </a:solidFill>
@@ -8277,12 +8257,12 @@
         </p:nvSpPr>
         <p:spPr>
           <a:xfrm>
-            <a:off x="457200" y="4572000"/>
-            <a:ext cx="8229600" cy="1005840"/>
+            <a:off x="365760" y="4937760"/>
+            <a:ext cx="8412480" cy="914400"/>
           </a:xfrm>
           <a:prstGeom prst="roundRect">
             <a:avLst>
-              <a:gd name="adj" fmla="val 10000"/>
+              <a:gd name="adj" fmla="val 8000"/>
             </a:avLst>
           </a:prstGeom>
           <a:solidFill>
@@ -8312,7 +8292,7 @@
           <a:p>
             <a:pPr algn="ctr">
               <a:lnSpc>
-                <a:spcPct val="130000"/>
+                <a:spcPct val="120000"/>
               </a:lnSpc>
               <a:defRPr sz="1700" b="1">
                 <a:solidFill>
@@ -8347,7 +8327,7 @@
         </p:blipFill>
         <p:spPr>
           <a:xfrm>
-            <a:off x="7589520" y="274320"/>
+            <a:off x="7589520" y="228600"/>
             <a:ext cx="1188720" cy="711889"/>
           </a:xfrm>
           <a:prstGeom prst="rect">
@@ -8363,7 +8343,7 @@
         </p:nvSpPr>
         <p:spPr>
           <a:xfrm>
-            <a:off x="0" y="6492240"/>
+            <a:off x="0" y="6446520"/>
             <a:ext cx="9144000" cy="25400"/>
           </a:xfrm>
           <a:prstGeom prst="rect">
@@ -8406,8 +8386,8 @@
         </p:nvSpPr>
         <p:spPr>
           <a:xfrm>
-            <a:off x="457200" y="6537960"/>
-            <a:ext cx="8229600" cy="274320"/>
+            <a:off x="365760" y="6510528"/>
+            <a:ext cx="8229600" cy="228600"/>
           </a:xfrm>
           <a:prstGeom prst="rect">
             <a:avLst/>
@@ -8468,8 +8448,8 @@
         </p:nvSpPr>
         <p:spPr>
           <a:xfrm>
-            <a:off x="457200" y="457200"/>
-            <a:ext cx="7315200" cy="365760"/>
+            <a:off x="365760" y="365760"/>
+            <a:ext cx="7315200" cy="274320"/>
           </a:xfrm>
           <a:prstGeom prst="rect">
             <a:avLst/>
@@ -8483,7 +8463,7 @@
           <a:lstStyle/>
           <a:p>
             <a:pPr>
-              <a:defRPr sz="1200" b="1">
+              <a:defRPr sz="1100" b="1">
                 <a:solidFill>
                   <a:srgbClr val="FFC947"/>
                 </a:solidFill>
@@ -8504,8 +8484,8 @@
         </p:nvSpPr>
         <p:spPr>
           <a:xfrm>
-            <a:off x="457200" y="822960"/>
-            <a:ext cx="7315200" cy="1097280"/>
+            <a:off x="365760" y="685800"/>
+            <a:ext cx="8229600" cy="822960"/>
           </a:xfrm>
           <a:prstGeom prst="rect">
             <a:avLst/>
@@ -8519,7 +8499,7 @@
           <a:lstStyle/>
           <a:p>
             <a:pPr>
-              <a:defRPr sz="3600" b="1">
+              <a:defRPr sz="3200" b="1">
                 <a:solidFill>
                   <a:srgbClr val="F8FAFC"/>
                 </a:solidFill>
@@ -8540,8 +8520,8 @@
         </p:nvSpPr>
         <p:spPr>
           <a:xfrm>
-            <a:off x="457200" y="2011680"/>
-            <a:ext cx="50800" cy="2560320"/>
+            <a:off x="365760" y="1645920"/>
+            <a:ext cx="38100" cy="2560320"/>
           </a:xfrm>
           <a:prstGeom prst="rect">
             <a:avLst/>
@@ -8583,8 +8563,8 @@
         </p:nvSpPr>
         <p:spPr>
           <a:xfrm>
-            <a:off x="685800" y="2011680"/>
-            <a:ext cx="3657600" cy="365760"/>
+            <a:off x="548640" y="1645920"/>
+            <a:ext cx="3657600" cy="320040"/>
           </a:xfrm>
           <a:prstGeom prst="rect">
             <a:avLst/>
@@ -8599,9 +8579,9 @@
           <a:p>
             <a:pPr algn="l">
               <a:lnSpc>
-                <a:spcPct val="140000"/>
+                <a:spcPct val="130000"/>
               </a:lnSpc>
-              <a:defRPr sz="1600" b="1">
+              <a:defRPr sz="1400" b="1">
                 <a:solidFill>
                   <a:srgbClr val="FFC947"/>
                 </a:solidFill>
@@ -8622,8 +8602,8 @@
         </p:nvSpPr>
         <p:spPr>
           <a:xfrm>
-            <a:off x="685800" y="2377440"/>
-            <a:ext cx="3657600" cy="1828800"/>
+            <a:off x="548640" y="2011680"/>
+            <a:ext cx="3840480" cy="1828800"/>
           </a:xfrm>
           <a:prstGeom prst="rect">
             <a:avLst/>
@@ -8638,12 +8618,12 @@
           <a:p>
             <a:pPr>
               <a:lnSpc>
-                <a:spcPct val="160000"/>
+                <a:spcPct val="150000"/>
               </a:lnSpc>
               <a:spcAft>
-                <a:spcPts val="600"/>
+                <a:spcPts val="400"/>
               </a:spcAft>
-              <a:defRPr sz="1500">
+              <a:defRPr sz="1400">
                 <a:solidFill>
                   <a:srgbClr val="CBD5E1"/>
                 </a:solidFill>
@@ -8657,12 +8637,12 @@
           <a:p>
             <a:pPr>
               <a:lnSpc>
-                <a:spcPct val="160000"/>
+                <a:spcPct val="150000"/>
               </a:lnSpc>
               <a:spcAft>
-                <a:spcPts val="600"/>
+                <a:spcPts val="400"/>
               </a:spcAft>
-              <a:defRPr sz="1500">
+              <a:defRPr sz="1400">
                 <a:solidFill>
                   <a:srgbClr val="CBD5E1"/>
                 </a:solidFill>
@@ -8676,12 +8656,12 @@
           <a:p>
             <a:pPr>
               <a:lnSpc>
-                <a:spcPct val="160000"/>
+                <a:spcPct val="150000"/>
               </a:lnSpc>
               <a:spcAft>
-                <a:spcPts val="600"/>
+                <a:spcPts val="400"/>
               </a:spcAft>
-              <a:defRPr sz="1500">
+              <a:defRPr sz="1400">
                 <a:solidFill>
                   <a:srgbClr val="CBD5E1"/>
                 </a:solidFill>
@@ -8702,8 +8682,8 @@
         </p:nvSpPr>
         <p:spPr>
           <a:xfrm>
-            <a:off x="4754880" y="2011680"/>
-            <a:ext cx="50800" cy="2560320"/>
+            <a:off x="4754880" y="1645920"/>
+            <a:ext cx="38100" cy="2560320"/>
           </a:xfrm>
           <a:prstGeom prst="rect">
             <a:avLst/>
@@ -8745,8 +8725,8 @@
         </p:nvSpPr>
         <p:spPr>
           <a:xfrm>
-            <a:off x="4983480" y="2011680"/>
-            <a:ext cx="3657600" cy="365760"/>
+            <a:off x="4937760" y="1645920"/>
+            <a:ext cx="3657600" cy="320040"/>
           </a:xfrm>
           <a:prstGeom prst="rect">
             <a:avLst/>
@@ -8761,9 +8741,9 @@
           <a:p>
             <a:pPr algn="l">
               <a:lnSpc>
-                <a:spcPct val="140000"/>
+                <a:spcPct val="130000"/>
               </a:lnSpc>
-              <a:defRPr sz="1600" b="1">
+              <a:defRPr sz="1400" b="1">
                 <a:solidFill>
                   <a:srgbClr val="FFC947"/>
                 </a:solidFill>
@@ -8784,7 +8764,7 @@
         </p:nvSpPr>
         <p:spPr>
           <a:xfrm>
-            <a:off x="4983480" y="2377440"/>
+            <a:off x="4937760" y="2011680"/>
             <a:ext cx="3840480" cy="2011680"/>
           </a:xfrm>
           <a:prstGeom prst="rect">
@@ -8800,12 +8780,12 @@
           <a:p>
             <a:pPr>
               <a:lnSpc>
-                <a:spcPct val="160000"/>
+                <a:spcPct val="150000"/>
               </a:lnSpc>
               <a:spcAft>
-                <a:spcPts val="600"/>
+                <a:spcPts val="400"/>
               </a:spcAft>
-              <a:defRPr sz="1500">
+              <a:defRPr sz="1400">
                 <a:solidFill>
                   <a:srgbClr val="CBD5E1"/>
                 </a:solidFill>
@@ -8819,12 +8799,12 @@
           <a:p>
             <a:pPr>
               <a:lnSpc>
-                <a:spcPct val="160000"/>
+                <a:spcPct val="150000"/>
               </a:lnSpc>
               <a:spcAft>
-                <a:spcPts val="600"/>
+                <a:spcPts val="400"/>
               </a:spcAft>
-              <a:defRPr sz="1500">
+              <a:defRPr sz="1400">
                 <a:solidFill>
                   <a:srgbClr val="CBD5E1"/>
                 </a:solidFill>
@@ -8838,12 +8818,12 @@
           <a:p>
             <a:pPr>
               <a:lnSpc>
-                <a:spcPct val="160000"/>
+                <a:spcPct val="150000"/>
               </a:lnSpc>
               <a:spcAft>
-                <a:spcPts val="600"/>
+                <a:spcPts val="400"/>
               </a:spcAft>
-              <a:defRPr sz="1500">
+              <a:defRPr sz="1400">
                 <a:solidFill>
                   <a:srgbClr val="CBD5E1"/>
                 </a:solidFill>
@@ -8857,12 +8837,12 @@
           <a:p>
             <a:pPr>
               <a:lnSpc>
-                <a:spcPct val="160000"/>
+                <a:spcPct val="150000"/>
               </a:lnSpc>
               <a:spcAft>
-                <a:spcPts val="600"/>
+                <a:spcPts val="400"/>
               </a:spcAft>
-              <a:defRPr sz="1500">
+              <a:defRPr sz="1400">
                 <a:solidFill>
                   <a:srgbClr val="CBD5E1"/>
                 </a:solidFill>
@@ -8883,12 +8863,12 @@
         </p:nvSpPr>
         <p:spPr>
           <a:xfrm>
-            <a:off x="457200" y="4846320"/>
-            <a:ext cx="8229600" cy="1005840"/>
+            <a:off x="365760" y="4937760"/>
+            <a:ext cx="8412480" cy="914400"/>
           </a:xfrm>
           <a:prstGeom prst="roundRect">
             <a:avLst>
-              <a:gd name="adj" fmla="val 10000"/>
+              <a:gd name="adj" fmla="val 8000"/>
             </a:avLst>
           </a:prstGeom>
           <a:solidFill>
@@ -8918,7 +8898,7 @@
           <a:p>
             <a:pPr algn="ctr">
               <a:lnSpc>
-                <a:spcPct val="130000"/>
+                <a:spcPct val="120000"/>
               </a:lnSpc>
               <a:defRPr sz="1700" b="1">
                 <a:solidFill>
@@ -8953,7 +8933,7 @@
         </p:blipFill>
         <p:spPr>
           <a:xfrm>
-            <a:off x="7589520" y="274320"/>
+            <a:off x="7589520" y="228600"/>
             <a:ext cx="1188720" cy="711889"/>
           </a:xfrm>
           <a:prstGeom prst="rect">
@@ -8969,7 +8949,7 @@
         </p:nvSpPr>
         <p:spPr>
           <a:xfrm>
-            <a:off x="0" y="6492240"/>
+            <a:off x="0" y="6446520"/>
             <a:ext cx="9144000" cy="25400"/>
           </a:xfrm>
           <a:prstGeom prst="rect">
@@ -9012,8 +8992,8 @@
         </p:nvSpPr>
         <p:spPr>
           <a:xfrm>
-            <a:off x="457200" y="6537960"/>
-            <a:ext cx="8229600" cy="274320"/>
+            <a:off x="365760" y="6510528"/>
+            <a:ext cx="8229600" cy="228600"/>
           </a:xfrm>
           <a:prstGeom prst="rect">
             <a:avLst/>
@@ -9074,8 +9054,8 @@
         </p:nvSpPr>
         <p:spPr>
           <a:xfrm>
-            <a:off x="457200" y="457200"/>
-            <a:ext cx="7315200" cy="365760"/>
+            <a:off x="365760" y="365760"/>
+            <a:ext cx="7315200" cy="274320"/>
           </a:xfrm>
           <a:prstGeom prst="rect">
             <a:avLst/>
@@ -9089,7 +9069,7 @@
           <a:lstStyle/>
           <a:p>
             <a:pPr>
-              <a:defRPr sz="1200" b="1">
+              <a:defRPr sz="1100" b="1">
                 <a:solidFill>
                   <a:srgbClr val="FFC947"/>
                 </a:solidFill>
@@ -9110,8 +9090,8 @@
         </p:nvSpPr>
         <p:spPr>
           <a:xfrm>
-            <a:off x="457200" y="822960"/>
-            <a:ext cx="7315200" cy="1097280"/>
+            <a:off x="365760" y="685800"/>
+            <a:ext cx="8229600" cy="822960"/>
           </a:xfrm>
           <a:prstGeom prst="rect">
             <a:avLst/>
@@ -9125,7 +9105,7 @@
           <a:lstStyle/>
           <a:p>
             <a:pPr>
-              <a:defRPr sz="3000" b="1">
+              <a:defRPr sz="3200" b="1">
                 <a:solidFill>
                   <a:srgbClr val="F8FAFC"/>
                 </a:solidFill>
@@ -9133,11 +9113,7 @@
               </a:defRPr>
             </a:pPr>
             <a:r>
-              <a:t>Warum Teams, SharePoint und Ablage</a:t>
-            </a:r>
-            <a:br/>
-            <a:r>
-              <a:t>das Problem nicht lösen</a:t>
+              <a:t>Warum Teams, SharePoint und Ablage das Problem nicht lösen</a:t>
             </a:r>
           </a:p>
         </p:txBody>
@@ -9150,8 +9126,8 @@
         </p:nvSpPr>
         <p:spPr>
           <a:xfrm>
-            <a:off x="457200" y="2103120"/>
-            <a:ext cx="8229600" cy="457200"/>
+            <a:off x="365760" y="1737360"/>
+            <a:ext cx="8229600" cy="365760"/>
           </a:xfrm>
           <a:prstGeom prst="rect">
             <a:avLst/>
@@ -9166,9 +9142,9 @@
           <a:p>
             <a:pPr algn="l">
               <a:lnSpc>
-                <a:spcPct val="140000"/>
+                <a:spcPct val="130000"/>
               </a:lnSpc>
-              <a:defRPr sz="2200" b="1">
+              <a:defRPr sz="2000" b="1">
                 <a:solidFill>
                   <a:srgbClr val="FFC947"/>
                 </a:solidFill>
@@ -9189,8 +9165,8 @@
         </p:nvSpPr>
         <p:spPr>
           <a:xfrm>
-            <a:off x="457200" y="2606040"/>
-            <a:ext cx="8229600" cy="12700"/>
+            <a:off x="365760" y="2194560"/>
+            <a:ext cx="8412480" cy="12700"/>
           </a:xfrm>
           <a:prstGeom prst="rect">
             <a:avLst/>
@@ -9232,8 +9208,8 @@
         </p:nvSpPr>
         <p:spPr>
           <a:xfrm>
-            <a:off x="457200" y="2834640"/>
-            <a:ext cx="8229600" cy="1828800"/>
+            <a:off x="365760" y="2468880"/>
+            <a:ext cx="8412480" cy="2194560"/>
           </a:xfrm>
           <a:prstGeom prst="rect">
             <a:avLst/>
@@ -9248,12 +9224,12 @@
           <a:p>
             <a:pPr>
               <a:lnSpc>
-                <a:spcPct val="160000"/>
+                <a:spcPct val="150000"/>
               </a:lnSpc>
               <a:spcAft>
-                <a:spcPts val="600"/>
+                <a:spcPts val="400"/>
               </a:spcAft>
-              <a:defRPr sz="1600">
+              <a:defRPr sz="1400">
                 <a:solidFill>
                   <a:srgbClr val="CBD5E1"/>
                 </a:solidFill>
@@ -9267,12 +9243,12 @@
           <a:p>
             <a:pPr>
               <a:lnSpc>
-                <a:spcPct val="160000"/>
+                <a:spcPct val="150000"/>
               </a:lnSpc>
               <a:spcAft>
-                <a:spcPts val="600"/>
+                <a:spcPts val="400"/>
               </a:spcAft>
-              <a:defRPr sz="1600">
+              <a:defRPr sz="1400">
                 <a:solidFill>
                   <a:srgbClr val="CBD5E1"/>
                 </a:solidFill>
@@ -9286,12 +9262,12 @@
           <a:p>
             <a:pPr>
               <a:lnSpc>
-                <a:spcPct val="160000"/>
+                <a:spcPct val="150000"/>
               </a:lnSpc>
               <a:spcAft>
-                <a:spcPts val="600"/>
+                <a:spcPts val="400"/>
               </a:spcAft>
-              <a:defRPr sz="1600">
+              <a:defRPr sz="1400">
                 <a:solidFill>
                   <a:srgbClr val="CBD5E1"/>
                 </a:solidFill>
@@ -9305,12 +9281,12 @@
           <a:p>
             <a:pPr>
               <a:lnSpc>
-                <a:spcPct val="160000"/>
+                <a:spcPct val="150000"/>
               </a:lnSpc>
               <a:spcAft>
-                <a:spcPts val="600"/>
+                <a:spcPts val="400"/>
               </a:spcAft>
-              <a:defRPr sz="1600">
+              <a:defRPr sz="1400">
                 <a:solidFill>
                   <a:srgbClr val="CBD5E1"/>
                 </a:solidFill>
@@ -9331,12 +9307,12 @@
         </p:nvSpPr>
         <p:spPr>
           <a:xfrm>
-            <a:off x="457200" y="4846320"/>
-            <a:ext cx="8229600" cy="1005840"/>
+            <a:off x="365760" y="4937760"/>
+            <a:ext cx="8412480" cy="914400"/>
           </a:xfrm>
           <a:prstGeom prst="roundRect">
             <a:avLst>
-              <a:gd name="adj" fmla="val 10000"/>
+              <a:gd name="adj" fmla="val 8000"/>
             </a:avLst>
           </a:prstGeom>
           <a:solidFill>
@@ -9366,9 +9342,9 @@
           <a:p>
             <a:pPr algn="ctr">
               <a:lnSpc>
-                <a:spcPct val="130000"/>
+                <a:spcPct val="120000"/>
               </a:lnSpc>
-              <a:defRPr sz="2000" b="1">
+              <a:defRPr sz="1700" b="1">
                 <a:solidFill>
                   <a:srgbClr val="0A1931"/>
                 </a:solidFill>
@@ -9376,11 +9352,7 @@
               </a:defRPr>
             </a:pPr>
             <a:r>
-              <a:t>Viele Unternehmen haben Speicher.</a:t>
-            </a:r>
-            <a:br/>
-            <a:r>
-              <a:t>Was fehlt, ist ein Gedächtnis.</a:t>
+              <a:t>Viele Unternehmen haben Speicher. Was fehlt, ist ein Gedächtnis.</a:t>
             </a:r>
           </a:p>
         </p:txBody>
@@ -9401,7 +9373,7 @@
         </p:blipFill>
         <p:spPr>
           <a:xfrm>
-            <a:off x="7589520" y="274320"/>
+            <a:off x="7589520" y="228600"/>
             <a:ext cx="1188720" cy="711889"/>
           </a:xfrm>
           <a:prstGeom prst="rect">
@@ -9417,7 +9389,7 @@
         </p:nvSpPr>
         <p:spPr>
           <a:xfrm>
-            <a:off x="0" y="6492240"/>
+            <a:off x="0" y="6446520"/>
             <a:ext cx="9144000" cy="25400"/>
           </a:xfrm>
           <a:prstGeom prst="rect">
@@ -9460,8 +9432,8 @@
         </p:nvSpPr>
         <p:spPr>
           <a:xfrm>
-            <a:off x="457200" y="6537960"/>
-            <a:ext cx="8229600" cy="274320"/>
+            <a:off x="365760" y="6510528"/>
+            <a:ext cx="8229600" cy="228600"/>
           </a:xfrm>
           <a:prstGeom prst="rect">
             <a:avLst/>
@@ -9522,8 +9494,8 @@
         </p:nvSpPr>
         <p:spPr>
           <a:xfrm>
-            <a:off x="457200" y="457200"/>
-            <a:ext cx="7315200" cy="365760"/>
+            <a:off x="365760" y="365760"/>
+            <a:ext cx="7315200" cy="274320"/>
           </a:xfrm>
           <a:prstGeom prst="rect">
             <a:avLst/>
@@ -9537,7 +9509,7 @@
           <a:lstStyle/>
           <a:p>
             <a:pPr>
-              <a:defRPr sz="1200" b="1">
+              <a:defRPr sz="1100" b="1">
                 <a:solidFill>
                   <a:srgbClr val="FFC947"/>
                 </a:solidFill>
@@ -9558,8 +9530,8 @@
         </p:nvSpPr>
         <p:spPr>
           <a:xfrm>
-            <a:off x="457200" y="822960"/>
-            <a:ext cx="7315200" cy="1097280"/>
+            <a:off x="365760" y="685800"/>
+            <a:ext cx="8229600" cy="822960"/>
           </a:xfrm>
           <a:prstGeom prst="rect">
             <a:avLst/>
@@ -9573,7 +9545,7 @@
           <a:lstStyle/>
           <a:p>
             <a:pPr>
-              <a:defRPr sz="3600" b="1">
+              <a:defRPr sz="3200" b="1">
                 <a:solidFill>
                   <a:srgbClr val="F8FAFC"/>
                 </a:solidFill>
@@ -9594,8 +9566,8 @@
         </p:nvSpPr>
         <p:spPr>
           <a:xfrm>
-            <a:off x="457200" y="1828800"/>
-            <a:ext cx="8229600" cy="365760"/>
+            <a:off x="365760" y="1645920"/>
+            <a:ext cx="8229600" cy="320040"/>
           </a:xfrm>
           <a:prstGeom prst="rect">
             <a:avLst/>
@@ -9610,9 +9582,9 @@
           <a:p>
             <a:pPr algn="l">
               <a:lnSpc>
-                <a:spcPct val="140000"/>
+                <a:spcPct val="130000"/>
               </a:lnSpc>
-              <a:defRPr sz="1600" b="0">
+              <a:defRPr sz="1400" b="0">
                 <a:solidFill>
                   <a:srgbClr val="CBD5E1"/>
                 </a:solidFill>
@@ -9633,8 +9605,8 @@
         </p:nvSpPr>
         <p:spPr>
           <a:xfrm>
-            <a:off x="457200" y="2377440"/>
-            <a:ext cx="502920" cy="502920"/>
+            <a:off x="365760" y="2103120"/>
+            <a:ext cx="411480" cy="411480"/>
           </a:xfrm>
           <a:prstGeom prst="ellipse">
             <a:avLst/>
@@ -9665,7 +9637,7 @@
           <a:lstStyle/>
           <a:p>
             <a:pPr algn="ctr">
-              <a:defRPr sz="1800" b="1">
+              <a:defRPr sz="1600" b="1">
                 <a:solidFill>
                   <a:srgbClr val="0A1931"/>
                 </a:solidFill>
@@ -9685,8 +9657,8 @@
         </p:nvSpPr>
         <p:spPr>
           <a:xfrm>
-            <a:off x="1097280" y="2468880"/>
-            <a:ext cx="7315200" cy="457200"/>
+            <a:off x="914400" y="2176272"/>
+            <a:ext cx="7315200" cy="365760"/>
           </a:xfrm>
           <a:prstGeom prst="rect">
             <a:avLst/>
@@ -9701,9 +9673,9 @@
           <a:p>
             <a:pPr algn="l">
               <a:lnSpc>
-                <a:spcPct val="140000"/>
+                <a:spcPct val="130000"/>
               </a:lnSpc>
-              <a:defRPr sz="2000" b="0">
+              <a:defRPr sz="1800" b="0">
                 <a:solidFill>
                   <a:srgbClr val="F8FAFC"/>
                 </a:solidFill>
@@ -9724,8 +9696,8 @@
         </p:nvSpPr>
         <p:spPr>
           <a:xfrm>
-            <a:off x="457200" y="3063240"/>
-            <a:ext cx="502920" cy="502920"/>
+            <a:off x="365760" y="2697479"/>
+            <a:ext cx="411480" cy="411480"/>
           </a:xfrm>
           <a:prstGeom prst="ellipse">
             <a:avLst/>
@@ -9756,7 +9728,7 @@
           <a:lstStyle/>
           <a:p>
             <a:pPr algn="ctr">
-              <a:defRPr sz="1800" b="1">
+              <a:defRPr sz="1600" b="1">
                 <a:solidFill>
                   <a:srgbClr val="0A1931"/>
                 </a:solidFill>
@@ -9776,8 +9748,8 @@
         </p:nvSpPr>
         <p:spPr>
           <a:xfrm>
-            <a:off x="1097280" y="3154680"/>
-            <a:ext cx="7315200" cy="457200"/>
+            <a:off x="914400" y="2770632"/>
+            <a:ext cx="7315200" cy="365760"/>
           </a:xfrm>
           <a:prstGeom prst="rect">
             <a:avLst/>
@@ -9792,9 +9764,9 @@
           <a:p>
             <a:pPr algn="l">
               <a:lnSpc>
-                <a:spcPct val="140000"/>
+                <a:spcPct val="130000"/>
               </a:lnSpc>
-              <a:defRPr sz="2000" b="0">
+              <a:defRPr sz="1800" b="0">
                 <a:solidFill>
                   <a:srgbClr val="F8FAFC"/>
                 </a:solidFill>
@@ -9815,8 +9787,8 @@
         </p:nvSpPr>
         <p:spPr>
           <a:xfrm>
-            <a:off x="457200" y="3749039"/>
-            <a:ext cx="502920" cy="502920"/>
+            <a:off x="365760" y="3291839"/>
+            <a:ext cx="411480" cy="411480"/>
           </a:xfrm>
           <a:prstGeom prst="ellipse">
             <a:avLst/>
@@ -9847,7 +9819,7 @@
           <a:lstStyle/>
           <a:p>
             <a:pPr algn="ctr">
-              <a:defRPr sz="1800" b="1">
+              <a:defRPr sz="1600" b="1">
                 <a:solidFill>
                   <a:srgbClr val="0A1931"/>
                 </a:solidFill>
@@ -9867,8 +9839,8 @@
         </p:nvSpPr>
         <p:spPr>
           <a:xfrm>
-            <a:off x="1097280" y="3840479"/>
-            <a:ext cx="7315200" cy="457200"/>
+            <a:off x="914400" y="3364991"/>
+            <a:ext cx="7315200" cy="365760"/>
           </a:xfrm>
           <a:prstGeom prst="rect">
             <a:avLst/>
@@ -9883,9 +9855,9 @@
           <a:p>
             <a:pPr algn="l">
               <a:lnSpc>
-                <a:spcPct val="140000"/>
+                <a:spcPct val="130000"/>
               </a:lnSpc>
-              <a:defRPr sz="2000" b="0">
+              <a:defRPr sz="1800" b="0">
                 <a:solidFill>
                   <a:srgbClr val="F8FAFC"/>
                 </a:solidFill>
@@ -9906,12 +9878,12 @@
         </p:nvSpPr>
         <p:spPr>
           <a:xfrm>
-            <a:off x="457200" y="4846320"/>
-            <a:ext cx="8229600" cy="1005840"/>
+            <a:off x="365760" y="4937760"/>
+            <a:ext cx="8412480" cy="914400"/>
           </a:xfrm>
           <a:prstGeom prst="roundRect">
             <a:avLst>
-              <a:gd name="adj" fmla="val 10000"/>
+              <a:gd name="adj" fmla="val 8000"/>
             </a:avLst>
           </a:prstGeom>
           <a:solidFill>
@@ -9941,7 +9913,7 @@
           <a:p>
             <a:pPr algn="ctr">
               <a:lnSpc>
-                <a:spcPct val="130000"/>
+                <a:spcPct val="120000"/>
               </a:lnSpc>
               <a:defRPr sz="1700" b="1">
                 <a:solidFill>
@@ -9976,7 +9948,7 @@
         </p:blipFill>
         <p:spPr>
           <a:xfrm>
-            <a:off x="7589520" y="274320"/>
+            <a:off x="7589520" y="228600"/>
             <a:ext cx="1188720" cy="711889"/>
           </a:xfrm>
           <a:prstGeom prst="rect">
@@ -9992,7 +9964,7 @@
         </p:nvSpPr>
         <p:spPr>
           <a:xfrm>
-            <a:off x="0" y="6492240"/>
+            <a:off x="0" y="6446520"/>
             <a:ext cx="9144000" cy="25400"/>
           </a:xfrm>
           <a:prstGeom prst="rect">
@@ -10035,8 +10007,8 @@
         </p:nvSpPr>
         <p:spPr>
           <a:xfrm>
-            <a:off x="457200" y="6537960"/>
-            <a:ext cx="8229600" cy="274320"/>
+            <a:off x="365760" y="6510528"/>
+            <a:ext cx="8229600" cy="228600"/>
           </a:xfrm>
           <a:prstGeom prst="rect">
             <a:avLst/>
@@ -10097,8 +10069,8 @@
         </p:nvSpPr>
         <p:spPr>
           <a:xfrm>
-            <a:off x="274320" y="274320"/>
-            <a:ext cx="914400" cy="914400"/>
+            <a:off x="274320" y="228600"/>
+            <a:ext cx="1097280" cy="731520"/>
           </a:xfrm>
           <a:prstGeom prst="rect">
             <a:avLst/>
@@ -10112,10 +10084,11 @@
           <a:lstStyle/>
           <a:p>
             <a:pPr>
-              <a:defRPr sz="4800" b="1">
+              <a:defRPr sz="4400" b="1">
                 <a:solidFill>
                   <a:srgbClr val="FFC947"/>
                 </a:solidFill>
+                <a:latin typeface="Arial"/>
               </a:defRPr>
             </a:pPr>
             <a:r>
@@ -10132,8 +10105,8 @@
         </p:nvSpPr>
         <p:spPr>
           <a:xfrm>
-            <a:off x="1371600" y="457200"/>
-            <a:ext cx="7315200" cy="365760"/>
+            <a:off x="365760" y="365760"/>
+            <a:ext cx="7315200" cy="274320"/>
           </a:xfrm>
           <a:prstGeom prst="rect">
             <a:avLst/>
@@ -10147,7 +10120,7 @@
           <a:lstStyle/>
           <a:p>
             <a:pPr>
-              <a:defRPr sz="1200" b="1">
+              <a:defRPr sz="1100" b="1">
                 <a:solidFill>
                   <a:srgbClr val="FFC947"/>
                 </a:solidFill>
@@ -10168,8 +10141,8 @@
         </p:nvSpPr>
         <p:spPr>
           <a:xfrm>
-            <a:off x="457200" y="1005840"/>
-            <a:ext cx="7315200" cy="1097280"/>
+            <a:off x="365760" y="685800"/>
+            <a:ext cx="8229600" cy="822960"/>
           </a:xfrm>
           <a:prstGeom prst="rect">
             <a:avLst/>
@@ -10183,7 +10156,7 @@
           <a:lstStyle/>
           <a:p>
             <a:pPr>
-              <a:defRPr sz="3600" b="1">
+              <a:defRPr sz="3200" b="1">
                 <a:solidFill>
                   <a:srgbClr val="F8FAFC"/>
                 </a:solidFill>
@@ -10204,8 +10177,8 @@
         </p:nvSpPr>
         <p:spPr>
           <a:xfrm>
-            <a:off x="457200" y="1828800"/>
-            <a:ext cx="3931920" cy="2377440"/>
+            <a:off x="365760" y="1645920"/>
+            <a:ext cx="4023360" cy="2560320"/>
           </a:xfrm>
           <a:prstGeom prst="roundRect">
             <a:avLst/>
@@ -10249,8 +10222,8 @@
         </p:nvSpPr>
         <p:spPr>
           <a:xfrm>
-            <a:off x="640080" y="1965960"/>
-            <a:ext cx="3566160" cy="365760"/>
+            <a:off x="502920" y="1755648"/>
+            <a:ext cx="3749040" cy="320040"/>
           </a:xfrm>
           <a:prstGeom prst="rect">
             <a:avLst/>
@@ -10265,7 +10238,7 @@
           <a:p>
             <a:pPr algn="l">
               <a:lnSpc>
-                <a:spcPct val="140000"/>
+                <a:spcPct val="130000"/>
               </a:lnSpc>
               <a:defRPr sz="1400" b="1">
                 <a:solidFill>
@@ -10288,8 +10261,8 @@
         </p:nvSpPr>
         <p:spPr>
           <a:xfrm>
-            <a:off x="640080" y="2286000"/>
-            <a:ext cx="3566160" cy="1828800"/>
+            <a:off x="502920" y="2057400"/>
+            <a:ext cx="3749040" cy="2057400"/>
           </a:xfrm>
           <a:prstGeom prst="rect">
             <a:avLst/>
@@ -10304,12 +10277,12 @@
           <a:p>
             <a:pPr>
               <a:lnSpc>
-                <a:spcPct val="160000"/>
+                <a:spcPct val="150000"/>
               </a:lnSpc>
               <a:spcAft>
-                <a:spcPts val="600"/>
+                <a:spcPts val="400"/>
               </a:spcAft>
-              <a:defRPr sz="1300">
+              <a:defRPr sz="1400">
                 <a:solidFill>
                   <a:srgbClr val="CBD5E1"/>
                 </a:solidFill>
@@ -10323,12 +10296,12 @@
           <a:p>
             <a:pPr>
               <a:lnSpc>
-                <a:spcPct val="160000"/>
+                <a:spcPct val="150000"/>
               </a:lnSpc>
               <a:spcAft>
-                <a:spcPts val="600"/>
+                <a:spcPts val="400"/>
               </a:spcAft>
-              <a:defRPr sz="1300">
+              <a:defRPr sz="1400">
                 <a:solidFill>
                   <a:srgbClr val="CBD5E1"/>
                 </a:solidFill>
@@ -10342,12 +10315,12 @@
           <a:p>
             <a:pPr>
               <a:lnSpc>
-                <a:spcPct val="160000"/>
+                <a:spcPct val="150000"/>
               </a:lnSpc>
               <a:spcAft>
-                <a:spcPts val="600"/>
+                <a:spcPts val="400"/>
               </a:spcAft>
-              <a:defRPr sz="1300">
+              <a:defRPr sz="1400">
                 <a:solidFill>
                   <a:srgbClr val="CBD5E1"/>
                 </a:solidFill>
@@ -10361,12 +10334,12 @@
           <a:p>
             <a:pPr>
               <a:lnSpc>
-                <a:spcPct val="160000"/>
+                <a:spcPct val="150000"/>
               </a:lnSpc>
               <a:spcAft>
-                <a:spcPts val="600"/>
+                <a:spcPts val="400"/>
               </a:spcAft>
-              <a:defRPr sz="1300">
+              <a:defRPr sz="1400">
                 <a:solidFill>
                   <a:srgbClr val="CBD5E1"/>
                 </a:solidFill>
@@ -10380,12 +10353,12 @@
           <a:p>
             <a:pPr>
               <a:lnSpc>
-                <a:spcPct val="160000"/>
+                <a:spcPct val="150000"/>
               </a:lnSpc>
               <a:spcAft>
-                <a:spcPts val="600"/>
+                <a:spcPts val="400"/>
               </a:spcAft>
-              <a:defRPr sz="1300">
+              <a:defRPr sz="1400">
                 <a:solidFill>
                   <a:srgbClr val="CBD5E1"/>
                 </a:solidFill>
@@ -10399,12 +10372,12 @@
           <a:p>
             <a:pPr>
               <a:lnSpc>
-                <a:spcPct val="160000"/>
+                <a:spcPct val="150000"/>
               </a:lnSpc>
               <a:spcAft>
-                <a:spcPts val="600"/>
+                <a:spcPts val="400"/>
               </a:spcAft>
-              <a:defRPr sz="1300">
+              <a:defRPr sz="1400">
                 <a:solidFill>
                   <a:srgbClr val="CBD5E1"/>
                 </a:solidFill>
@@ -10412,7 +10385,7 @@
               </a:defRPr>
             </a:pPr>
             <a:r>
-              <a:t>•  Zeichnungen mit Positionsnummern</a:t>
+              <a:t>•  Zeichnungen</a:t>
             </a:r>
           </a:p>
         </p:txBody>
@@ -10425,8 +10398,8 @@
         </p:nvSpPr>
         <p:spPr>
           <a:xfrm>
-            <a:off x="4754880" y="1828800"/>
-            <a:ext cx="3931920" cy="2377440"/>
+            <a:off x="4754880" y="1645920"/>
+            <a:ext cx="4023360" cy="2560320"/>
           </a:xfrm>
           <a:prstGeom prst="roundRect">
             <a:avLst/>
@@ -10470,8 +10443,8 @@
         </p:nvSpPr>
         <p:spPr>
           <a:xfrm>
-            <a:off x="4937760" y="1965960"/>
-            <a:ext cx="3566160" cy="365760"/>
+            <a:off x="4892040" y="1755648"/>
+            <a:ext cx="3749040" cy="320040"/>
           </a:xfrm>
           <a:prstGeom prst="rect">
             <a:avLst/>
@@ -10486,7 +10459,7 @@
           <a:p>
             <a:pPr algn="l">
               <a:lnSpc>
-                <a:spcPct val="140000"/>
+                <a:spcPct val="130000"/>
               </a:lnSpc>
               <a:defRPr sz="1400" b="1">
                 <a:solidFill>
@@ -10509,8 +10482,8 @@
         </p:nvSpPr>
         <p:spPr>
           <a:xfrm>
-            <a:off x="4937760" y="2286000"/>
-            <a:ext cx="3566160" cy="1828800"/>
+            <a:off x="4892040" y="2057400"/>
+            <a:ext cx="3749040" cy="2057400"/>
           </a:xfrm>
           <a:prstGeom prst="rect">
             <a:avLst/>
@@ -10525,12 +10498,12 @@
           <a:p>
             <a:pPr>
               <a:lnSpc>
-                <a:spcPct val="160000"/>
+                <a:spcPct val="150000"/>
               </a:lnSpc>
               <a:spcAft>
-                <a:spcPts val="600"/>
+                <a:spcPts val="400"/>
               </a:spcAft>
-              <a:defRPr sz="1300">
+              <a:defRPr sz="1400">
                 <a:solidFill>
                   <a:srgbClr val="CBD5E1"/>
                 </a:solidFill>
@@ -10544,12 +10517,12 @@
           <a:p>
             <a:pPr>
               <a:lnSpc>
-                <a:spcPct val="160000"/>
+                <a:spcPct val="150000"/>
               </a:lnSpc>
               <a:spcAft>
-                <a:spcPts val="600"/>
+                <a:spcPts val="400"/>
               </a:spcAft>
-              <a:defRPr sz="1300">
+              <a:defRPr sz="1400">
                 <a:solidFill>
                   <a:srgbClr val="CBD5E1"/>
                 </a:solidFill>
@@ -10563,12 +10536,12 @@
           <a:p>
             <a:pPr>
               <a:lnSpc>
-                <a:spcPct val="160000"/>
+                <a:spcPct val="150000"/>
               </a:lnSpc>
               <a:spcAft>
-                <a:spcPts val="600"/>
+                <a:spcPts val="400"/>
               </a:spcAft>
-              <a:defRPr sz="1300">
+              <a:defRPr sz="1400">
                 <a:solidFill>
                   <a:srgbClr val="CBD5E1"/>
                 </a:solidFill>
@@ -10582,12 +10555,12 @@
           <a:p>
             <a:pPr>
               <a:lnSpc>
-                <a:spcPct val="160000"/>
+                <a:spcPct val="150000"/>
               </a:lnSpc>
               <a:spcAft>
-                <a:spcPts val="600"/>
+                <a:spcPts val="400"/>
               </a:spcAft>
-              <a:defRPr sz="1300">
+              <a:defRPr sz="1400">
                 <a:solidFill>
                   <a:srgbClr val="CBD5E1"/>
                 </a:solidFill>
@@ -10595,7 +10568,7 @@
               </a:defRPr>
             </a:pPr>
             <a:r>
-              <a:t>•  Strukturierte Daten mit klaren Feldern</a:t>
+              <a:t>•  Strukturierte Daten</a:t>
             </a:r>
           </a:p>
         </p:txBody>
@@ -10608,12 +10581,12 @@
         </p:nvSpPr>
         <p:spPr>
           <a:xfrm>
-            <a:off x="457200" y="4572000"/>
-            <a:ext cx="8229600" cy="868680"/>
+            <a:off x="365760" y="4937760"/>
+            <a:ext cx="8412480" cy="914400"/>
           </a:xfrm>
           <a:prstGeom prst="roundRect">
             <a:avLst>
-              <a:gd name="adj" fmla="val 10000"/>
+              <a:gd name="adj" fmla="val 8000"/>
             </a:avLst>
           </a:prstGeom>
           <a:solidFill>
@@ -10643,9 +10616,9 @@
           <a:p>
             <a:pPr algn="ctr">
               <a:lnSpc>
-                <a:spcPct val="130000"/>
+                <a:spcPct val="120000"/>
               </a:lnSpc>
-              <a:defRPr sz="1800" b="1">
+              <a:defRPr sz="1700" b="1">
                 <a:solidFill>
                   <a:srgbClr val="0A1931"/>
                 </a:solidFill>
@@ -10674,7 +10647,7 @@
         </p:blipFill>
         <p:spPr>
           <a:xfrm>
-            <a:off x="7589520" y="274320"/>
+            <a:off x="7589520" y="228600"/>
             <a:ext cx="1188720" cy="711889"/>
           </a:xfrm>
           <a:prstGeom prst="rect">
@@ -10690,7 +10663,7 @@
         </p:nvSpPr>
         <p:spPr>
           <a:xfrm>
-            <a:off x="0" y="6492240"/>
+            <a:off x="0" y="6446520"/>
             <a:ext cx="9144000" cy="25400"/>
           </a:xfrm>
           <a:prstGeom prst="rect">
@@ -10733,8 +10706,8 @@
         </p:nvSpPr>
         <p:spPr>
           <a:xfrm>
-            <a:off x="457200" y="6537960"/>
-            <a:ext cx="8229600" cy="274320"/>
+            <a:off x="365760" y="6510528"/>
+            <a:ext cx="8229600" cy="228600"/>
           </a:xfrm>
           <a:prstGeom prst="rect">
             <a:avLst/>
@@ -10795,8 +10768,8 @@
         </p:nvSpPr>
         <p:spPr>
           <a:xfrm>
-            <a:off x="274320" y="274320"/>
-            <a:ext cx="914400" cy="914400"/>
+            <a:off x="274320" y="228600"/>
+            <a:ext cx="1097280" cy="731520"/>
           </a:xfrm>
           <a:prstGeom prst="rect">
             <a:avLst/>
@@ -10810,10 +10783,11 @@
           <a:lstStyle/>
           <a:p>
             <a:pPr>
-              <a:defRPr sz="4800" b="1">
+              <a:defRPr sz="4400" b="1">
                 <a:solidFill>
                   <a:srgbClr val="FFC947"/>
                 </a:solidFill>
+                <a:latin typeface="Arial"/>
               </a:defRPr>
             </a:pPr>
             <a:r>
@@ -10830,8 +10804,8 @@
         </p:nvSpPr>
         <p:spPr>
           <a:xfrm>
-            <a:off x="1371600" y="457200"/>
-            <a:ext cx="7315200" cy="365760"/>
+            <a:off x="365760" y="365760"/>
+            <a:ext cx="7315200" cy="274320"/>
           </a:xfrm>
           <a:prstGeom prst="rect">
             <a:avLst/>
@@ -10845,7 +10819,7 @@
           <a:lstStyle/>
           <a:p>
             <a:pPr>
-              <a:defRPr sz="1200" b="1">
+              <a:defRPr sz="1100" b="1">
                 <a:solidFill>
                   <a:srgbClr val="FFC947"/>
                 </a:solidFill>
@@ -10866,8 +10840,8 @@
         </p:nvSpPr>
         <p:spPr>
           <a:xfrm>
-            <a:off x="457200" y="1005840"/>
-            <a:ext cx="7315200" cy="1097280"/>
+            <a:off x="365760" y="685800"/>
+            <a:ext cx="8229600" cy="822960"/>
           </a:xfrm>
           <a:prstGeom prst="rect">
             <a:avLst/>
@@ -10881,7 +10855,7 @@
           <a:lstStyle/>
           <a:p>
             <a:pPr>
-              <a:defRPr sz="3600" b="1">
+              <a:defRPr sz="3200" b="1">
                 <a:solidFill>
                   <a:srgbClr val="F8FAFC"/>
                 </a:solidFill>
@@ -10902,8 +10876,8 @@
         </p:nvSpPr>
         <p:spPr>
           <a:xfrm>
-            <a:off x="457200" y="1828800"/>
-            <a:ext cx="3931920" cy="1828800"/>
+            <a:off x="365760" y="1645920"/>
+            <a:ext cx="4023360" cy="1828800"/>
           </a:xfrm>
           <a:prstGeom prst="roundRect">
             <a:avLst/>
@@ -10947,8 +10921,8 @@
         </p:nvSpPr>
         <p:spPr>
           <a:xfrm>
-            <a:off x="640080" y="1965960"/>
-            <a:ext cx="3566160" cy="365760"/>
+            <a:off x="502920" y="1755648"/>
+            <a:ext cx="3749040" cy="320040"/>
           </a:xfrm>
           <a:prstGeom prst="rect">
             <a:avLst/>
@@ -10963,7 +10937,7 @@
           <a:p>
             <a:pPr algn="l">
               <a:lnSpc>
-                <a:spcPct val="140000"/>
+                <a:spcPct val="130000"/>
               </a:lnSpc>
               <a:defRPr sz="1400" b="1">
                 <a:solidFill>
@@ -10986,8 +10960,8 @@
         </p:nvSpPr>
         <p:spPr>
           <a:xfrm>
-            <a:off x="640080" y="2286000"/>
-            <a:ext cx="3566160" cy="1280160"/>
+            <a:off x="502920" y="2057400"/>
+            <a:ext cx="3749040" cy="1325880"/>
           </a:xfrm>
           <a:prstGeom prst="rect">
             <a:avLst/>
@@ -11002,12 +10976,12 @@
           <a:p>
             <a:pPr>
               <a:lnSpc>
-                <a:spcPct val="160000"/>
+                <a:spcPct val="150000"/>
               </a:lnSpc>
               <a:spcAft>
-                <a:spcPts val="600"/>
+                <a:spcPts val="400"/>
               </a:spcAft>
-              <a:defRPr sz="1300">
+              <a:defRPr sz="1400">
                 <a:solidFill>
                   <a:srgbClr val="CBD5E1"/>
                 </a:solidFill>
@@ -11021,12 +10995,12 @@
           <a:p>
             <a:pPr>
               <a:lnSpc>
-                <a:spcPct val="160000"/>
+                <a:spcPct val="150000"/>
               </a:lnSpc>
               <a:spcAft>
-                <a:spcPts val="600"/>
+                <a:spcPts val="400"/>
               </a:spcAft>
-              <a:defRPr sz="1300">
+              <a:defRPr sz="1400">
                 <a:solidFill>
                   <a:srgbClr val="CBD5E1"/>
                 </a:solidFill>
@@ -11034,18 +11008,18 @@
               </a:defRPr>
             </a:pPr>
             <a:r>
-              <a:t>•  Lösungen sind implizit und werden nie dokumentiert</a:t>
+              <a:t>•  Lösungen sind implizit und undokumentiert</a:t>
             </a:r>
           </a:p>
           <a:p>
             <a:pPr>
               <a:lnSpc>
-                <a:spcPct val="160000"/>
+                <a:spcPct val="150000"/>
               </a:lnSpc>
               <a:spcAft>
-                <a:spcPts val="600"/>
+                <a:spcPts val="400"/>
               </a:spcAft>
-              <a:defRPr sz="1300">
+              <a:defRPr sz="1400">
                 <a:solidFill>
                   <a:srgbClr val="CBD5E1"/>
                 </a:solidFill>
@@ -11066,8 +11040,8 @@
         </p:nvSpPr>
         <p:spPr>
           <a:xfrm>
-            <a:off x="4754880" y="1828800"/>
-            <a:ext cx="3931920" cy="1828800"/>
+            <a:off x="4754880" y="1645920"/>
+            <a:ext cx="4023360" cy="1828800"/>
           </a:xfrm>
           <a:prstGeom prst="roundRect">
             <a:avLst/>
@@ -11111,8 +11085,8 @@
         </p:nvSpPr>
         <p:spPr>
           <a:xfrm>
-            <a:off x="4937760" y="1965960"/>
-            <a:ext cx="3566160" cy="365760"/>
+            <a:off x="4892040" y="1755648"/>
+            <a:ext cx="3749040" cy="320040"/>
           </a:xfrm>
           <a:prstGeom prst="rect">
             <a:avLst/>
@@ -11127,7 +11101,7 @@
           <a:p>
             <a:pPr algn="l">
               <a:lnSpc>
-                <a:spcPct val="140000"/>
+                <a:spcPct val="130000"/>
               </a:lnSpc>
               <a:defRPr sz="1400" b="1">
                 <a:solidFill>
@@ -11150,8 +11124,8 @@
         </p:nvSpPr>
         <p:spPr>
           <a:xfrm>
-            <a:off x="4937760" y="2286000"/>
-            <a:ext cx="3566160" cy="1280160"/>
+            <a:off x="4892040" y="2057400"/>
+            <a:ext cx="3749040" cy="1325880"/>
           </a:xfrm>
           <a:prstGeom prst="rect">
             <a:avLst/>
@@ -11166,12 +11140,12 @@
           <a:p>
             <a:pPr>
               <a:lnSpc>
-                <a:spcPct val="160000"/>
+                <a:spcPct val="150000"/>
               </a:lnSpc>
               <a:spcAft>
-                <a:spcPts val="600"/>
+                <a:spcPts val="400"/>
               </a:spcAft>
-              <a:defRPr sz="1300">
+              <a:defRPr sz="1400">
                 <a:solidFill>
                   <a:srgbClr val="CBD5E1"/>
                 </a:solidFill>
@@ -11185,12 +11159,12 @@
           <a:p>
             <a:pPr>
               <a:lnSpc>
-                <a:spcPct val="160000"/>
+                <a:spcPct val="150000"/>
               </a:lnSpc>
               <a:spcAft>
-                <a:spcPts val="600"/>
+                <a:spcPts val="400"/>
               </a:spcAft>
-              <a:defRPr sz="1300">
+              <a:defRPr sz="1400">
                 <a:solidFill>
                   <a:srgbClr val="CBD5E1"/>
                 </a:solidFill>
@@ -11204,12 +11178,12 @@
           <a:p>
             <a:pPr>
               <a:lnSpc>
-                <a:spcPct val="160000"/>
+                <a:spcPct val="150000"/>
               </a:lnSpc>
               <a:spcAft>
-                <a:spcPts val="600"/>
+                <a:spcPts val="400"/>
               </a:spcAft>
-              <a:defRPr sz="1300">
+              <a:defRPr sz="1400">
                 <a:solidFill>
                   <a:srgbClr val="CBD5E1"/>
                 </a:solidFill>
@@ -11223,12 +11197,12 @@
           <a:p>
             <a:pPr>
               <a:lnSpc>
-                <a:spcPct val="160000"/>
+                <a:spcPct val="150000"/>
               </a:lnSpc>
               <a:spcAft>
-                <a:spcPts val="600"/>
+                <a:spcPts val="400"/>
               </a:spcAft>
-              <a:defRPr sz="1300">
+              <a:defRPr sz="1400">
                 <a:solidFill>
                   <a:srgbClr val="CBD5E1"/>
                 </a:solidFill>
@@ -11237,25 +11211,6 @@
             </a:pPr>
             <a:r>
               <a:t>•  Teile und Hinweise</a:t>
-            </a:r>
-          </a:p>
-          <a:p>
-            <a:pPr>
-              <a:lnSpc>
-                <a:spcPct val="160000"/>
-              </a:lnSpc>
-              <a:spcAft>
-                <a:spcPts val="600"/>
-              </a:spcAft>
-              <a:defRPr sz="1300">
-                <a:solidFill>
-                  <a:srgbClr val="CBD5E1"/>
-                </a:solidFill>
-                <a:latin typeface="Arial"/>
-              </a:defRPr>
-            </a:pPr>
-            <a:r>
-              <a:t>•  Quelle / Referenz</a:t>
             </a:r>
           </a:p>
         </p:txBody>
@@ -11268,8 +11223,8 @@
         </p:nvSpPr>
         <p:spPr>
           <a:xfrm>
-            <a:off x="457200" y="3840480"/>
-            <a:ext cx="8229600" cy="12700"/>
+            <a:off x="365760" y="3657600"/>
+            <a:ext cx="8412480" cy="12700"/>
           </a:xfrm>
           <a:prstGeom prst="rect">
             <a:avLst/>
@@ -11311,8 +11266,8 @@
         </p:nvSpPr>
         <p:spPr>
           <a:xfrm>
-            <a:off x="457200" y="3977639"/>
-            <a:ext cx="1097280" cy="365760"/>
+            <a:off x="365760" y="3794760"/>
+            <a:ext cx="1097280" cy="274320"/>
           </a:xfrm>
           <a:prstGeom prst="rect">
             <a:avLst/>
@@ -11327,7 +11282,7 @@
           <a:p>
             <a:pPr algn="l">
               <a:lnSpc>
-                <a:spcPct val="140000"/>
+                <a:spcPct val="130000"/>
               </a:lnSpc>
               <a:defRPr sz="1400" b="1">
                 <a:solidFill>
@@ -11350,8 +11305,8 @@
         </p:nvSpPr>
         <p:spPr>
           <a:xfrm>
-            <a:off x="1554480" y="3977639"/>
-            <a:ext cx="6858000" cy="365760"/>
+            <a:off x="1371600" y="3794760"/>
+            <a:ext cx="7315200" cy="274320"/>
           </a:xfrm>
           <a:prstGeom prst="rect">
             <a:avLst/>
@@ -11366,7 +11321,7 @@
           <a:p>
             <a:pPr algn="l">
               <a:lnSpc>
-                <a:spcPct val="140000"/>
+                <a:spcPct val="130000"/>
               </a:lnSpc>
               <a:defRPr sz="1400" b="0">
                 <a:solidFill>
@@ -11376,7 +11331,7 @@
               </a:defRPr>
             </a:pPr>
             <a:r>
-              <a:t>Wissen bleibt im Unternehmen  •  Einarbeitung wird schneller  •  Qualität wird stabiler</a:t>
+              <a:t>Wissen bleibt im Unternehmen  •  Einarbeitung schneller  •  Qualität stabiler</a:t>
             </a:r>
           </a:p>
         </p:txBody>
@@ -11389,12 +11344,12 @@
         </p:nvSpPr>
         <p:spPr>
           <a:xfrm>
-            <a:off x="457200" y="4572000"/>
-            <a:ext cx="8229600" cy="868680"/>
+            <a:off x="365760" y="4297680"/>
+            <a:ext cx="8412480" cy="914400"/>
           </a:xfrm>
           <a:prstGeom prst="roundRect">
             <a:avLst>
-              <a:gd name="adj" fmla="val 10000"/>
+              <a:gd name="adj" fmla="val 8000"/>
             </a:avLst>
           </a:prstGeom>
           <a:solidFill>
@@ -11424,9 +11379,9 @@
           <a:p>
             <a:pPr algn="ctr">
               <a:lnSpc>
-                <a:spcPct val="130000"/>
+                <a:spcPct val="120000"/>
               </a:lnSpc>
-              <a:defRPr sz="1900" b="1">
+              <a:defRPr sz="1700" b="1">
                 <a:solidFill>
                   <a:srgbClr val="0A1931"/>
                 </a:solidFill>
@@ -11455,7 +11410,7 @@
         </p:blipFill>
         <p:spPr>
           <a:xfrm>
-            <a:off x="7589520" y="274320"/>
+            <a:off x="7589520" y="228600"/>
             <a:ext cx="1188720" cy="711889"/>
           </a:xfrm>
           <a:prstGeom prst="rect">
@@ -11471,7 +11426,7 @@
         </p:nvSpPr>
         <p:spPr>
           <a:xfrm>
-            <a:off x="0" y="6492240"/>
+            <a:off x="0" y="6446520"/>
             <a:ext cx="9144000" cy="25400"/>
           </a:xfrm>
           <a:prstGeom prst="rect">
@@ -11514,8 +11469,8 @@
         </p:nvSpPr>
         <p:spPr>
           <a:xfrm>
-            <a:off x="457200" y="6537960"/>
-            <a:ext cx="8229600" cy="274320"/>
+            <a:off x="365760" y="6510528"/>
+            <a:ext cx="8229600" cy="228600"/>
           </a:xfrm>
           <a:prstGeom prst="rect">
             <a:avLst/>
@@ -11576,8 +11531,8 @@
         </p:nvSpPr>
         <p:spPr>
           <a:xfrm>
-            <a:off x="274320" y="274320"/>
-            <a:ext cx="914400" cy="914400"/>
+            <a:off x="274320" y="228600"/>
+            <a:ext cx="1097280" cy="731520"/>
           </a:xfrm>
           <a:prstGeom prst="rect">
             <a:avLst/>
@@ -11591,10 +11546,11 @@
           <a:lstStyle/>
           <a:p>
             <a:pPr>
-              <a:defRPr sz="4800" b="1">
+              <a:defRPr sz="4400" b="1">
                 <a:solidFill>
                   <a:srgbClr val="FFC947"/>
                 </a:solidFill>
+                <a:latin typeface="Arial"/>
               </a:defRPr>
             </a:pPr>
             <a:r>
@@ -11611,8 +11567,8 @@
         </p:nvSpPr>
         <p:spPr>
           <a:xfrm>
-            <a:off x="1371600" y="457200"/>
-            <a:ext cx="7315200" cy="365760"/>
+            <a:off x="365760" y="365760"/>
+            <a:ext cx="7315200" cy="274320"/>
           </a:xfrm>
           <a:prstGeom prst="rect">
             <a:avLst/>
@@ -11626,7 +11582,7 @@
           <a:lstStyle/>
           <a:p>
             <a:pPr>
-              <a:defRPr sz="1200" b="1">
+              <a:defRPr sz="1100" b="1">
                 <a:solidFill>
                   <a:srgbClr val="FFC947"/>
                 </a:solidFill>
@@ -11647,8 +11603,8 @@
         </p:nvSpPr>
         <p:spPr>
           <a:xfrm>
-            <a:off x="457200" y="1005840"/>
-            <a:ext cx="7315200" cy="1097280"/>
+            <a:off x="365760" y="685800"/>
+            <a:ext cx="8229600" cy="822960"/>
           </a:xfrm>
           <a:prstGeom prst="rect">
             <a:avLst/>
@@ -11662,7 +11618,7 @@
           <a:lstStyle/>
           <a:p>
             <a:pPr>
-              <a:defRPr sz="3600" b="1">
+              <a:defRPr sz="3200" b="1">
                 <a:solidFill>
                   <a:srgbClr val="F8FAFC"/>
                 </a:solidFill>
@@ -11683,8 +11639,8 @@
         </p:nvSpPr>
         <p:spPr>
           <a:xfrm>
-            <a:off x="457200" y="1828800"/>
-            <a:ext cx="2651760" cy="1645920"/>
+            <a:off x="365760" y="1645920"/>
+            <a:ext cx="2697480" cy="1737360"/>
           </a:xfrm>
           <a:prstGeom prst="roundRect">
             <a:avLst/>
@@ -11728,8 +11684,8 @@
         </p:nvSpPr>
         <p:spPr>
           <a:xfrm>
-            <a:off x="640080" y="1965960"/>
-            <a:ext cx="2286000" cy="365760"/>
+            <a:off x="502920" y="1755648"/>
+            <a:ext cx="2423160" cy="320040"/>
           </a:xfrm>
           <a:prstGeom prst="rect">
             <a:avLst/>
@@ -11744,7 +11700,7 @@
           <a:p>
             <a:pPr algn="l">
               <a:lnSpc>
-                <a:spcPct val="140000"/>
+                <a:spcPct val="130000"/>
               </a:lnSpc>
               <a:defRPr sz="1400" b="1">
                 <a:solidFill>
@@ -11767,8 +11723,8 @@
         </p:nvSpPr>
         <p:spPr>
           <a:xfrm>
-            <a:off x="640080" y="2286000"/>
-            <a:ext cx="2286000" cy="1097280"/>
+            <a:off x="502920" y="2057400"/>
+            <a:ext cx="2423160" cy="1234440"/>
           </a:xfrm>
           <a:prstGeom prst="rect">
             <a:avLst/>
@@ -11783,12 +11739,12 @@
           <a:p>
             <a:pPr>
               <a:lnSpc>
-                <a:spcPct val="160000"/>
+                <a:spcPct val="150000"/>
               </a:lnSpc>
               <a:spcAft>
-                <a:spcPts val="600"/>
+                <a:spcPts val="400"/>
               </a:spcAft>
-              <a:defRPr sz="1300">
+              <a:defRPr sz="1400">
                 <a:solidFill>
                   <a:srgbClr val="CBD5E1"/>
                 </a:solidFill>
@@ -11802,12 +11758,12 @@
           <a:p>
             <a:pPr>
               <a:lnSpc>
-                <a:spcPct val="160000"/>
+                <a:spcPct val="150000"/>
               </a:lnSpc>
               <a:spcAft>
-                <a:spcPts val="600"/>
+                <a:spcPts val="400"/>
               </a:spcAft>
-              <a:defRPr sz="1300">
+              <a:defRPr sz="1400">
                 <a:solidFill>
                   <a:srgbClr val="CBD5E1"/>
                 </a:solidFill>
@@ -11828,8 +11784,8 @@
         </p:nvSpPr>
         <p:spPr>
           <a:xfrm>
-            <a:off x="3246120" y="1828800"/>
-            <a:ext cx="2651760" cy="1645920"/>
+            <a:off x="3200400" y="1645920"/>
+            <a:ext cx="2697480" cy="1737360"/>
           </a:xfrm>
           <a:prstGeom prst="roundRect">
             <a:avLst/>
@@ -11873,8 +11829,8 @@
         </p:nvSpPr>
         <p:spPr>
           <a:xfrm>
-            <a:off x="3429000" y="1965960"/>
-            <a:ext cx="2286000" cy="365760"/>
+            <a:off x="3337560" y="1755648"/>
+            <a:ext cx="2423160" cy="320040"/>
           </a:xfrm>
           <a:prstGeom prst="rect">
             <a:avLst/>
@@ -11889,7 +11845,7 @@
           <a:p>
             <a:pPr algn="l">
               <a:lnSpc>
-                <a:spcPct val="140000"/>
+                <a:spcPct val="130000"/>
               </a:lnSpc>
               <a:defRPr sz="1400" b="1">
                 <a:solidFill>
@@ -11912,8 +11868,8 @@
         </p:nvSpPr>
         <p:spPr>
           <a:xfrm>
-            <a:off x="3429000" y="2286000"/>
-            <a:ext cx="2286000" cy="1097280"/>
+            <a:off x="3337560" y="2057400"/>
+            <a:ext cx="2423160" cy="1234440"/>
           </a:xfrm>
           <a:prstGeom prst="rect">
             <a:avLst/>
@@ -11928,12 +11884,12 @@
           <a:p>
             <a:pPr>
               <a:lnSpc>
-                <a:spcPct val="160000"/>
+                <a:spcPct val="150000"/>
               </a:lnSpc>
               <a:spcAft>
-                <a:spcPts val="600"/>
+                <a:spcPts val="400"/>
               </a:spcAft>
-              <a:defRPr sz="1300">
+              <a:defRPr sz="1400">
                 <a:solidFill>
                   <a:srgbClr val="CBD5E1"/>
                 </a:solidFill>
@@ -11947,12 +11903,12 @@
           <a:p>
             <a:pPr>
               <a:lnSpc>
-                <a:spcPct val="160000"/>
+                <a:spcPct val="150000"/>
               </a:lnSpc>
               <a:spcAft>
-                <a:spcPts val="600"/>
+                <a:spcPts val="400"/>
               </a:spcAft>
-              <a:defRPr sz="1300">
+              <a:defRPr sz="1400">
                 <a:solidFill>
                   <a:srgbClr val="CBD5E1"/>
                 </a:solidFill>
@@ -11966,12 +11922,12 @@
           <a:p>
             <a:pPr>
               <a:lnSpc>
-                <a:spcPct val="160000"/>
+                <a:spcPct val="150000"/>
               </a:lnSpc>
               <a:spcAft>
-                <a:spcPts val="600"/>
+                <a:spcPts val="400"/>
               </a:spcAft>
-              <a:defRPr sz="1300">
+              <a:defRPr sz="1400">
                 <a:solidFill>
                   <a:srgbClr val="CBD5E1"/>
                 </a:solidFill>
@@ -11992,8 +11948,8 @@
         </p:nvSpPr>
         <p:spPr>
           <a:xfrm>
-            <a:off x="6035040" y="1828800"/>
-            <a:ext cx="2651760" cy="1645920"/>
+            <a:off x="6035040" y="1645920"/>
+            <a:ext cx="2697480" cy="1737360"/>
           </a:xfrm>
           <a:prstGeom prst="roundRect">
             <a:avLst/>
@@ -12037,8 +11993,8 @@
         </p:nvSpPr>
         <p:spPr>
           <a:xfrm>
-            <a:off x="6217920" y="1965960"/>
-            <a:ext cx="2286000" cy="365760"/>
+            <a:off x="6172200" y="1755648"/>
+            <a:ext cx="2423160" cy="320040"/>
           </a:xfrm>
           <a:prstGeom prst="rect">
             <a:avLst/>
@@ -12053,7 +12009,7 @@
           <a:p>
             <a:pPr algn="l">
               <a:lnSpc>
-                <a:spcPct val="140000"/>
+                <a:spcPct val="130000"/>
               </a:lnSpc>
               <a:defRPr sz="1400" b="1">
                 <a:solidFill>
@@ -12076,8 +12032,8 @@
         </p:nvSpPr>
         <p:spPr>
           <a:xfrm>
-            <a:off x="6217920" y="2286000"/>
-            <a:ext cx="2286000" cy="1097280"/>
+            <a:off x="6172200" y="2057400"/>
+            <a:ext cx="2423160" cy="1234440"/>
           </a:xfrm>
           <a:prstGeom prst="rect">
             <a:avLst/>
@@ -12092,12 +12048,12 @@
           <a:p>
             <a:pPr>
               <a:lnSpc>
-                <a:spcPct val="160000"/>
+                <a:spcPct val="150000"/>
               </a:lnSpc>
               <a:spcAft>
-                <a:spcPts val="600"/>
+                <a:spcPts val="400"/>
               </a:spcAft>
-              <a:defRPr sz="1300">
+              <a:defRPr sz="1400">
                 <a:solidFill>
                   <a:srgbClr val="CBD5E1"/>
                 </a:solidFill>
@@ -12111,12 +12067,12 @@
           <a:p>
             <a:pPr>
               <a:lnSpc>
-                <a:spcPct val="160000"/>
+                <a:spcPct val="150000"/>
               </a:lnSpc>
               <a:spcAft>
-                <a:spcPts val="600"/>
+                <a:spcPts val="400"/>
               </a:spcAft>
-              <a:defRPr sz="1300">
+              <a:defRPr sz="1400">
                 <a:solidFill>
                   <a:srgbClr val="CBD5E1"/>
                 </a:solidFill>
@@ -12130,12 +12086,12 @@
           <a:p>
             <a:pPr>
               <a:lnSpc>
-                <a:spcPct val="160000"/>
+                <a:spcPct val="150000"/>
               </a:lnSpc>
               <a:spcAft>
-                <a:spcPts val="600"/>
+                <a:spcPts val="400"/>
               </a:spcAft>
-              <a:defRPr sz="1300">
+              <a:defRPr sz="1400">
                 <a:solidFill>
                   <a:srgbClr val="CBD5E1"/>
                 </a:solidFill>
@@ -12156,8 +12112,8 @@
         </p:nvSpPr>
         <p:spPr>
           <a:xfrm>
-            <a:off x="457200" y="3749039"/>
-            <a:ext cx="8229600" cy="12700"/>
+            <a:off x="365760" y="3566160"/>
+            <a:ext cx="8412480" cy="12700"/>
           </a:xfrm>
           <a:prstGeom prst="rect">
             <a:avLst/>
@@ -12199,8 +12155,8 @@
         </p:nvSpPr>
         <p:spPr>
           <a:xfrm>
-            <a:off x="457200" y="3886200"/>
-            <a:ext cx="1097280" cy="365760"/>
+            <a:off x="365760" y="3703320"/>
+            <a:ext cx="1097280" cy="274320"/>
           </a:xfrm>
           <a:prstGeom prst="rect">
             <a:avLst/>
@@ -12215,7 +12171,7 @@
           <a:p>
             <a:pPr algn="l">
               <a:lnSpc>
-                <a:spcPct val="140000"/>
+                <a:spcPct val="130000"/>
               </a:lnSpc>
               <a:defRPr sz="1400" b="1">
                 <a:solidFill>
@@ -12238,8 +12194,8 @@
         </p:nvSpPr>
         <p:spPr>
           <a:xfrm>
-            <a:off x="1554480" y="3886200"/>
-            <a:ext cx="6858000" cy="365760"/>
+            <a:off x="1371600" y="3703320"/>
+            <a:ext cx="7315200" cy="274320"/>
           </a:xfrm>
           <a:prstGeom prst="rect">
             <a:avLst/>
@@ -12254,7 +12210,7 @@
           <a:p>
             <a:pPr algn="l">
               <a:lnSpc>
-                <a:spcPct val="140000"/>
+                <a:spcPct val="130000"/>
               </a:lnSpc>
               <a:defRPr sz="1400" b="0">
                 <a:solidFill>
@@ -12269,9 +12225,67 @@
           </a:p>
         </p:txBody>
       </p:sp>
+      <p:sp>
+        <p:nvSpPr>
+          <p:cNvPr id="17" name="Rounded Rectangle 16"/>
+          <p:cNvSpPr/>
+          <p:nvPr/>
+        </p:nvSpPr>
+        <p:spPr>
+          <a:xfrm>
+            <a:off x="365760" y="4206240"/>
+            <a:ext cx="8412480" cy="914400"/>
+          </a:xfrm>
+          <a:prstGeom prst="roundRect">
+            <a:avLst>
+              <a:gd name="adj" fmla="val 8000"/>
+            </a:avLst>
+          </a:prstGeom>
+          <a:solidFill>
+            <a:srgbClr val="FFC947"/>
+          </a:solidFill>
+          <a:ln>
+            <a:noFill/>
+          </a:ln>
+        </p:spPr>
+        <p:style>
+          <a:lnRef idx="1">
+            <a:schemeClr val="accent1"/>
+          </a:lnRef>
+          <a:fillRef idx="3">
+            <a:schemeClr val="accent1"/>
+          </a:fillRef>
+          <a:effectRef idx="2">
+            <a:schemeClr val="accent1"/>
+          </a:effectRef>
+          <a:fontRef idx="minor">
+            <a:schemeClr val="lt1"/>
+          </a:fontRef>
+        </p:style>
+        <p:txBody>
+          <a:bodyPr rtlCol="0" anchor="ctr" wrap="square"/>
+          <a:lstStyle/>
+          <a:p>
+            <a:pPr algn="ctr">
+              <a:lnSpc>
+                <a:spcPct val="120000"/>
+              </a:lnSpc>
+              <a:defRPr sz="1700" b="1">
+                <a:solidFill>
+                  <a:srgbClr val="0A1931"/>
+                </a:solidFill>
+                <a:latin typeface="Arial"/>
+              </a:defRPr>
+            </a:pPr>
+            <a:r>
+              <a:t>Schneller Zugriff auf vorhandenes Wissen.</a:t>
+            </a:r>
+          </a:p>
+        </p:txBody>
+      </p:sp>
       <p:pic>
         <p:nvPicPr>
-          <p:cNvPr id="17" name="Picture 16" descr="neuratex-logo.jpg"/>
+          <p:cNvPr id="18" name="Picture 17" descr="neuratex-logo.jpg"/>
           <p:cNvPicPr>
             <a:picLocks noChangeAspect="1"/>
           </p:cNvPicPr>
@@ -12285,7 +12299,7 @@
         </p:blipFill>
         <p:spPr>
           <a:xfrm>
-            <a:off x="7589520" y="274320"/>
+            <a:off x="7589520" y="228600"/>
             <a:ext cx="1188720" cy="711889"/>
           </a:xfrm>
           <a:prstGeom prst="rect">
@@ -12295,13 +12309,13 @@
       </p:pic>
       <p:sp>
         <p:nvSpPr>
-          <p:cNvPr id="18" name="Rectangle 17"/>
+          <p:cNvPr id="19" name="Rectangle 18"/>
           <p:cNvSpPr/>
           <p:nvPr/>
         </p:nvSpPr>
         <p:spPr>
           <a:xfrm>
-            <a:off x="0" y="6492240"/>
+            <a:off x="0" y="6446520"/>
             <a:ext cx="9144000" cy="25400"/>
           </a:xfrm>
           <a:prstGeom prst="rect">
@@ -12338,14 +12352,14 @@
       </p:sp>
       <p:sp>
         <p:nvSpPr>
-          <p:cNvPr id="19" name="TextBox 18"/>
+          <p:cNvPr id="20" name="TextBox 19"/>
           <p:cNvSpPr txBox="1"/>
           <p:nvPr/>
         </p:nvSpPr>
         <p:spPr>
           <a:xfrm>
-            <a:off x="457200" y="6537960"/>
-            <a:ext cx="8229600" cy="274320"/>
+            <a:off x="365760" y="6510528"/>
+            <a:ext cx="8229600" cy="228600"/>
           </a:xfrm>
           <a:prstGeom prst="rect">
             <a:avLst/>
@@ -12406,8 +12420,8 @@
         </p:nvSpPr>
         <p:spPr>
           <a:xfrm>
-            <a:off x="457200" y="457200"/>
-            <a:ext cx="7315200" cy="365760"/>
+            <a:off x="365760" y="365760"/>
+            <a:ext cx="7315200" cy="274320"/>
           </a:xfrm>
           <a:prstGeom prst="rect">
             <a:avLst/>
@@ -12421,7 +12435,7 @@
           <a:lstStyle/>
           <a:p>
             <a:pPr>
-              <a:defRPr sz="1200" b="1">
+              <a:defRPr sz="1100" b="1">
                 <a:solidFill>
                   <a:srgbClr val="FFC947"/>
                 </a:solidFill>
@@ -12442,8 +12456,8 @@
         </p:nvSpPr>
         <p:spPr>
           <a:xfrm>
-            <a:off x="457200" y="822960"/>
-            <a:ext cx="7315200" cy="1097280"/>
+            <a:off x="365760" y="685800"/>
+            <a:ext cx="8229600" cy="822960"/>
           </a:xfrm>
           <a:prstGeom prst="rect">
             <a:avLst/>
@@ -12457,7 +12471,7 @@
           <a:lstStyle/>
           <a:p>
             <a:pPr>
-              <a:defRPr sz="3600" b="1">
+              <a:defRPr sz="3200" b="1">
                 <a:solidFill>
                   <a:srgbClr val="F8FAFC"/>
                 </a:solidFill>
@@ -12478,8 +12492,8 @@
         </p:nvSpPr>
         <p:spPr>
           <a:xfrm>
-            <a:off x="457200" y="1920240"/>
-            <a:ext cx="2651760" cy="1005840"/>
+            <a:off x="365760" y="1645920"/>
+            <a:ext cx="2697480" cy="914400"/>
           </a:xfrm>
           <a:prstGeom prst="roundRect">
             <a:avLst/>
@@ -12523,8 +12537,8 @@
         </p:nvSpPr>
         <p:spPr>
           <a:xfrm>
-            <a:off x="548640" y="2011680"/>
-            <a:ext cx="2468880" cy="457200"/>
+            <a:off x="457200" y="1737360"/>
+            <a:ext cx="2514600" cy="320040"/>
           </a:xfrm>
           <a:prstGeom prst="rect">
             <a:avLst/>
@@ -12539,9 +12553,9 @@
           <a:p>
             <a:pPr algn="ctr">
               <a:lnSpc>
-                <a:spcPct val="140000"/>
+                <a:spcPct val="130000"/>
               </a:lnSpc>
-              <a:defRPr sz="1600" b="1">
+              <a:defRPr sz="1400" b="1">
                 <a:solidFill>
                   <a:srgbClr val="FFC947"/>
                 </a:solidFill>
@@ -12562,8 +12576,8 @@
         </p:nvSpPr>
         <p:spPr>
           <a:xfrm>
-            <a:off x="548640" y="2377440"/>
-            <a:ext cx="2468880" cy="365760"/>
+            <a:off x="457200" y="2103120"/>
+            <a:ext cx="2514600" cy="274320"/>
           </a:xfrm>
           <a:prstGeom prst="rect">
             <a:avLst/>
@@ -12578,9 +12592,9 @@
           <a:p>
             <a:pPr algn="ctr">
               <a:lnSpc>
-                <a:spcPct val="140000"/>
+                <a:spcPct val="130000"/>
               </a:lnSpc>
-              <a:defRPr sz="1300" b="0">
+              <a:defRPr sz="1400" b="0">
                 <a:solidFill>
                   <a:srgbClr val="CBD5E1"/>
                 </a:solidFill>
@@ -12601,8 +12615,8 @@
         </p:nvSpPr>
         <p:spPr>
           <a:xfrm>
-            <a:off x="3246120" y="1920240"/>
-            <a:ext cx="2651760" cy="1005840"/>
+            <a:off x="3200400" y="1645920"/>
+            <a:ext cx="2697480" cy="914400"/>
           </a:xfrm>
           <a:prstGeom prst="roundRect">
             <a:avLst/>
@@ -12646,8 +12660,8 @@
         </p:nvSpPr>
         <p:spPr>
           <a:xfrm>
-            <a:off x="3337560" y="2011680"/>
-            <a:ext cx="2468880" cy="457200"/>
+            <a:off x="3291840" y="1737360"/>
+            <a:ext cx="2514600" cy="320040"/>
           </a:xfrm>
           <a:prstGeom prst="rect">
             <a:avLst/>
@@ -12662,9 +12676,9 @@
           <a:p>
             <a:pPr algn="ctr">
               <a:lnSpc>
-                <a:spcPct val="140000"/>
+                <a:spcPct val="130000"/>
               </a:lnSpc>
-              <a:defRPr sz="1600" b="1">
+              <a:defRPr sz="1400" b="1">
                 <a:solidFill>
                   <a:srgbClr val="FFC947"/>
                 </a:solidFill>
@@ -12685,8 +12699,8 @@
         </p:nvSpPr>
         <p:spPr>
           <a:xfrm>
-            <a:off x="3337560" y="2377440"/>
-            <a:ext cx="2468880" cy="365760"/>
+            <a:off x="3291840" y="2103120"/>
+            <a:ext cx="2514600" cy="274320"/>
           </a:xfrm>
           <a:prstGeom prst="rect">
             <a:avLst/>
@@ -12701,9 +12715,9 @@
           <a:p>
             <a:pPr algn="ctr">
               <a:lnSpc>
-                <a:spcPct val="140000"/>
+                <a:spcPct val="130000"/>
               </a:lnSpc>
-              <a:defRPr sz="1300" b="0">
+              <a:defRPr sz="1400" b="0">
                 <a:solidFill>
                   <a:srgbClr val="CBD5E1"/>
                 </a:solidFill>
@@ -12724,8 +12738,8 @@
         </p:nvSpPr>
         <p:spPr>
           <a:xfrm>
-            <a:off x="6035040" y="1920240"/>
-            <a:ext cx="2651760" cy="1005840"/>
+            <a:off x="6035040" y="1645920"/>
+            <a:ext cx="2697480" cy="914400"/>
           </a:xfrm>
           <a:prstGeom prst="roundRect">
             <a:avLst/>
@@ -12769,8 +12783,8 @@
         </p:nvSpPr>
         <p:spPr>
           <a:xfrm>
-            <a:off x="6126480" y="2011680"/>
-            <a:ext cx="2468880" cy="457200"/>
+            <a:off x="6126479" y="1737360"/>
+            <a:ext cx="2514600" cy="320040"/>
           </a:xfrm>
           <a:prstGeom prst="rect">
             <a:avLst/>
@@ -12785,9 +12799,9 @@
           <a:p>
             <a:pPr algn="ctr">
               <a:lnSpc>
-                <a:spcPct val="140000"/>
+                <a:spcPct val="130000"/>
               </a:lnSpc>
-              <a:defRPr sz="1600" b="1">
+              <a:defRPr sz="1400" b="1">
                 <a:solidFill>
                   <a:srgbClr val="FFC947"/>
                 </a:solidFill>
@@ -12808,8 +12822,8 @@
         </p:nvSpPr>
         <p:spPr>
           <a:xfrm>
-            <a:off x="6126480" y="2377440"/>
-            <a:ext cx="2468880" cy="365760"/>
+            <a:off x="6126479" y="2103120"/>
+            <a:ext cx="2514600" cy="274320"/>
           </a:xfrm>
           <a:prstGeom prst="rect">
             <a:avLst/>
@@ -12824,9 +12838,9 @@
           <a:p>
             <a:pPr algn="ctr">
               <a:lnSpc>
-                <a:spcPct val="140000"/>
+                <a:spcPct val="130000"/>
               </a:lnSpc>
-              <a:defRPr sz="1300" b="0">
+              <a:defRPr sz="1400" b="0">
                 <a:solidFill>
                   <a:srgbClr val="CBD5E1"/>
                 </a:solidFill>
@@ -12847,8 +12861,8 @@
         </p:nvSpPr>
         <p:spPr>
           <a:xfrm>
-            <a:off x="3108960" y="2286000"/>
-            <a:ext cx="228600" cy="228600"/>
+            <a:off x="3063240" y="1965960"/>
+            <a:ext cx="182880" cy="182880"/>
           </a:xfrm>
           <a:prstGeom prst="rightArrow">
             <a:avLst/>
@@ -12890,8 +12904,8 @@
         </p:nvSpPr>
         <p:spPr>
           <a:xfrm>
-            <a:off x="5897880" y="2286000"/>
-            <a:ext cx="228600" cy="228600"/>
+            <a:off x="5897880" y="1965960"/>
+            <a:ext cx="182880" cy="182880"/>
           </a:xfrm>
           <a:prstGeom prst="rightArrow">
             <a:avLst/>
@@ -12933,8 +12947,8 @@
         </p:nvSpPr>
         <p:spPr>
           <a:xfrm>
-            <a:off x="457200" y="3200400"/>
-            <a:ext cx="8229600" cy="365760"/>
+            <a:off x="365760" y="2926080"/>
+            <a:ext cx="8229600" cy="320040"/>
           </a:xfrm>
           <a:prstGeom prst="rect">
             <a:avLst/>
@@ -12949,9 +12963,9 @@
           <a:p>
             <a:pPr algn="l">
               <a:lnSpc>
-                <a:spcPct val="140000"/>
+                <a:spcPct val="130000"/>
               </a:lnSpc>
-              <a:defRPr sz="1500" b="1">
+              <a:defRPr sz="1400" b="1">
                 <a:solidFill>
                   <a:srgbClr val="F8FAFC"/>
                 </a:solidFill>
@@ -12972,8 +12986,8 @@
         </p:nvSpPr>
         <p:spPr>
           <a:xfrm>
-            <a:off x="457200" y="3566160"/>
-            <a:ext cx="8229600" cy="1280160"/>
+            <a:off x="365760" y="3291840"/>
+            <a:ext cx="8229600" cy="1371600"/>
           </a:xfrm>
           <a:prstGeom prst="rect">
             <a:avLst/>
@@ -12988,12 +13002,12 @@
           <a:p>
             <a:pPr>
               <a:lnSpc>
-                <a:spcPct val="160000"/>
+                <a:spcPct val="150000"/>
               </a:lnSpc>
               <a:spcAft>
-                <a:spcPts val="600"/>
+                <a:spcPts val="400"/>
               </a:spcAft>
-              <a:defRPr sz="1500">
+              <a:defRPr sz="1400">
                 <a:solidFill>
                   <a:srgbClr val="CBD5E1"/>
                 </a:solidFill>
@@ -13007,12 +13021,12 @@
           <a:p>
             <a:pPr>
               <a:lnSpc>
-                <a:spcPct val="160000"/>
+                <a:spcPct val="150000"/>
               </a:lnSpc>
               <a:spcAft>
-                <a:spcPts val="600"/>
+                <a:spcPts val="400"/>
               </a:spcAft>
-              <a:defRPr sz="1500">
+              <a:defRPr sz="1400">
                 <a:solidFill>
                   <a:srgbClr val="CBD5E1"/>
                 </a:solidFill>
@@ -13026,12 +13040,12 @@
           <a:p>
             <a:pPr>
               <a:lnSpc>
-                <a:spcPct val="160000"/>
+                <a:spcPct val="150000"/>
               </a:lnSpc>
               <a:spcAft>
-                <a:spcPts val="600"/>
+                <a:spcPts val="400"/>
               </a:spcAft>
-              <a:defRPr sz="1500">
+              <a:defRPr sz="1400">
                 <a:solidFill>
                   <a:srgbClr val="CBD5E1"/>
                 </a:solidFill>
@@ -13052,12 +13066,12 @@
         </p:nvSpPr>
         <p:spPr>
           <a:xfrm>
-            <a:off x="457200" y="5120640"/>
-            <a:ext cx="8229600" cy="777240"/>
+            <a:off x="365760" y="4937760"/>
+            <a:ext cx="8412480" cy="914400"/>
           </a:xfrm>
           <a:prstGeom prst="roundRect">
             <a:avLst>
-              <a:gd name="adj" fmla="val 10000"/>
+              <a:gd name="adj" fmla="val 8000"/>
             </a:avLst>
           </a:prstGeom>
           <a:solidFill>
@@ -13087,9 +13101,9 @@
           <a:p>
             <a:pPr algn="ctr">
               <a:lnSpc>
-                <a:spcPct val="130000"/>
+                <a:spcPct val="120000"/>
               </a:lnSpc>
-              <a:defRPr sz="1800" b="1">
+              <a:defRPr sz="1700" b="1">
                 <a:solidFill>
                   <a:srgbClr val="0A1931"/>
                 </a:solidFill>
@@ -13118,7 +13132,7 @@
         </p:blipFill>
         <p:spPr>
           <a:xfrm>
-            <a:off x="7589520" y="274320"/>
+            <a:off x="7589520" y="228600"/>
             <a:ext cx="1188720" cy="711889"/>
           </a:xfrm>
           <a:prstGeom prst="rect">
@@ -13134,7 +13148,7 @@
         </p:nvSpPr>
         <p:spPr>
           <a:xfrm>
-            <a:off x="0" y="6492240"/>
+            <a:off x="0" y="6446520"/>
             <a:ext cx="9144000" cy="25400"/>
           </a:xfrm>
           <a:prstGeom prst="rect">
@@ -13177,8 +13191,8 @@
         </p:nvSpPr>
         <p:spPr>
           <a:xfrm>
-            <a:off x="457200" y="6537960"/>
-            <a:ext cx="8229600" cy="274320"/>
+            <a:off x="365760" y="6510528"/>
+            <a:ext cx="8229600" cy="228600"/>
           </a:xfrm>
           <a:prstGeom prst="rect">
             <a:avLst/>

</xml_diff>